<commit_message>
Add conversational speaker notes to all 38 slides
</commit_message>
<xml_diff>
--- a/docs/ghcp-getting-started.pptx
+++ b/docs/ghcp-getting-started.pptx
@@ -142,6 +142,3016 @@
     </a:lvl9pPr>
   </p:defaultTextStyle>
 </p:presentation>
+</file>
+
+<file path=ppt/notesMasters/notesMaster1.xml><?xml version="1.0" encoding="utf-8"?>
+<p:notesMaster xmlns:a="http://schemas.openxmlformats.org/drawingml/2006/main" xmlns:p="http://schemas.openxmlformats.org/presentationml/2006/main" xmlns:r="http://schemas.openxmlformats.org/officeDocument/2006/relationships">
+  <p:cSld>
+    <p:bg>
+      <p:bgRef idx="1001">
+        <a:schemeClr val="bg1"/>
+      </p:bgRef>
+    </p:bg>
+    <p:spTree>
+      <p:nvGrpSpPr>
+        <p:cNvPr id="1" name=""/>
+        <p:cNvGrpSpPr/>
+        <p:nvPr/>
+      </p:nvGrpSpPr>
+      <p:grpSpPr>
+        <a:xfrm>
+          <a:off x="0" y="0"/>
+          <a:ext cx="0" cy="0"/>
+          <a:chOff x="0" y="0"/>
+          <a:chExt cx="0" cy="0"/>
+        </a:xfrm>
+      </p:grpSpPr>
+      <p:sp>
+        <p:nvSpPr>
+          <p:cNvPr id="2" name="Header Placeholder 1"/>
+          <p:cNvSpPr>
+            <a:spLocks noGrp="1"/>
+          </p:cNvSpPr>
+          <p:nvPr>
+            <p:ph type="hdr" sz="quarter"/>
+          </p:nvPr>
+        </p:nvSpPr>
+        <p:spPr>
+          <a:xfrm>
+            <a:off x="0" y="0"/>
+            <a:ext cx="2971800" cy="457200"/>
+          </a:xfrm>
+          <a:prstGeom prst="rect">
+            <a:avLst/>
+          </a:prstGeom>
+        </p:spPr>
+        <p:txBody>
+          <a:bodyPr vert="horz" lIns="91440" tIns="45720" rIns="91440" bIns="45720" rtlCol="0"/>
+          <a:lstStyle>
+            <a:lvl1pPr algn="l">
+              <a:defRPr sz="1200"/>
+            </a:lvl1pPr>
+          </a:lstStyle>
+          <a:p>
+            <a:endParaRPr lang="en-US"/>
+          </a:p>
+        </p:txBody>
+      </p:sp>
+      <p:sp>
+        <p:nvSpPr>
+          <p:cNvPr id="3" name="Date Placeholder 2"/>
+          <p:cNvSpPr>
+            <a:spLocks noGrp="1"/>
+          </p:cNvSpPr>
+          <p:nvPr>
+            <p:ph type="dt" idx="1"/>
+          </p:nvPr>
+        </p:nvSpPr>
+        <p:spPr>
+          <a:xfrm>
+            <a:off x="3884613" y="0"/>
+            <a:ext cx="2971800" cy="457200"/>
+          </a:xfrm>
+          <a:prstGeom prst="rect">
+            <a:avLst/>
+          </a:prstGeom>
+        </p:spPr>
+        <p:txBody>
+          <a:bodyPr vert="horz" lIns="91440" tIns="45720" rIns="91440" bIns="45720" rtlCol="0"/>
+          <a:lstStyle>
+            <a:lvl1pPr algn="r">
+              <a:defRPr sz="1200"/>
+            </a:lvl1pPr>
+          </a:lstStyle>
+          <a:p>
+            <a:fld id="{0F89C1C7-3DCD-1040-A9CF-14679D8B5DDD}" type="datetimeFigureOut">
+              <a:rPr lang="en-US" smtClean="0"/>
+              <a:t>10/17/16</a:t>
+            </a:fld>
+            <a:endParaRPr lang="en-US"/>
+          </a:p>
+        </p:txBody>
+      </p:sp>
+      <p:sp>
+        <p:nvSpPr>
+          <p:cNvPr id="4" name="Slide Image Placeholder 3"/>
+          <p:cNvSpPr>
+            <a:spLocks noGrp="1" noRot="1" noChangeAspect="1"/>
+          </p:cNvSpPr>
+          <p:nvPr>
+            <p:ph type="sldImg" idx="2"/>
+          </p:nvPr>
+        </p:nvSpPr>
+        <p:spPr>
+          <a:xfrm>
+            <a:off x="1143000" y="685800"/>
+            <a:ext cx="4572000" cy="3429000"/>
+          </a:xfrm>
+          <a:prstGeom prst="rect">
+            <a:avLst/>
+          </a:prstGeom>
+          <a:noFill/>
+          <a:ln w="12700">
+            <a:solidFill>
+              <a:prstClr val="black"/>
+            </a:solidFill>
+          </a:ln>
+        </p:spPr>
+        <p:txBody>
+          <a:bodyPr vert="horz" lIns="91440" tIns="45720" rIns="91440" bIns="45720" rtlCol="0" anchor="ctr"/>
+          <a:lstStyle/>
+          <a:p>
+            <a:endParaRPr lang="en-US"/>
+          </a:p>
+        </p:txBody>
+      </p:sp>
+      <p:sp>
+        <p:nvSpPr>
+          <p:cNvPr id="5" name="Notes Placeholder 4"/>
+          <p:cNvSpPr>
+            <a:spLocks noGrp="1"/>
+          </p:cNvSpPr>
+          <p:nvPr>
+            <p:ph type="body" sz="quarter" idx="3"/>
+          </p:nvPr>
+        </p:nvSpPr>
+        <p:spPr>
+          <a:xfrm>
+            <a:off x="685800" y="4343400"/>
+            <a:ext cx="5486400" cy="4114800"/>
+          </a:xfrm>
+          <a:prstGeom prst="rect">
+            <a:avLst/>
+          </a:prstGeom>
+        </p:spPr>
+        <p:txBody>
+          <a:bodyPr vert="horz" lIns="91440" tIns="45720" rIns="91440" bIns="45720" rtlCol="0"/>
+          <a:lstStyle/>
+          <a:p>
+            <a:pPr lvl="0"/>
+            <a:r>
+              <a:rPr lang="en-US" smtClean="0"/>
+              <a:t>Click to edit Master text styles</a:t>
+            </a:r>
+          </a:p>
+          <a:p>
+            <a:pPr lvl="1"/>
+            <a:r>
+              <a:rPr lang="en-US" smtClean="0"/>
+              <a:t>Second level</a:t>
+            </a:r>
+          </a:p>
+          <a:p>
+            <a:pPr lvl="2"/>
+            <a:r>
+              <a:rPr lang="en-US" smtClean="0"/>
+              <a:t>Third level</a:t>
+            </a:r>
+          </a:p>
+          <a:p>
+            <a:pPr lvl="3"/>
+            <a:r>
+              <a:rPr lang="en-US" smtClean="0"/>
+              <a:t>Fourth level</a:t>
+            </a:r>
+          </a:p>
+          <a:p>
+            <a:pPr lvl="4"/>
+            <a:r>
+              <a:rPr lang="en-US" smtClean="0"/>
+              <a:t>Fifth level</a:t>
+            </a:r>
+            <a:endParaRPr lang="en-US"/>
+          </a:p>
+        </p:txBody>
+      </p:sp>
+      <p:sp>
+        <p:nvSpPr>
+          <p:cNvPr id="6" name="Footer Placeholder 5"/>
+          <p:cNvSpPr>
+            <a:spLocks noGrp="1"/>
+          </p:cNvSpPr>
+          <p:nvPr>
+            <p:ph type="ftr" sz="quarter" idx="4"/>
+          </p:nvPr>
+        </p:nvSpPr>
+        <p:spPr>
+          <a:xfrm>
+            <a:off x="0" y="8685213"/>
+            <a:ext cx="2971800" cy="457200"/>
+          </a:xfrm>
+          <a:prstGeom prst="rect">
+            <a:avLst/>
+          </a:prstGeom>
+        </p:spPr>
+        <p:txBody>
+          <a:bodyPr vert="horz" lIns="91440" tIns="45720" rIns="91440" bIns="45720" rtlCol="0" anchor="b"/>
+          <a:lstStyle>
+            <a:lvl1pPr algn="l">
+              <a:defRPr sz="1200"/>
+            </a:lvl1pPr>
+          </a:lstStyle>
+          <a:p>
+            <a:endParaRPr lang="en-US"/>
+          </a:p>
+        </p:txBody>
+      </p:sp>
+      <p:sp>
+        <p:nvSpPr>
+          <p:cNvPr id="7" name="Slide Number Placeholder 6"/>
+          <p:cNvSpPr>
+            <a:spLocks noGrp="1"/>
+          </p:cNvSpPr>
+          <p:nvPr>
+            <p:ph type="sldNum" sz="quarter" idx="5"/>
+          </p:nvPr>
+        </p:nvSpPr>
+        <p:spPr>
+          <a:xfrm>
+            <a:off x="3884613" y="8685213"/>
+            <a:ext cx="2971800" cy="457200"/>
+          </a:xfrm>
+          <a:prstGeom prst="rect">
+            <a:avLst/>
+          </a:prstGeom>
+        </p:spPr>
+        <p:txBody>
+          <a:bodyPr vert="horz" lIns="91440" tIns="45720" rIns="91440" bIns="45720" rtlCol="0" anchor="b"/>
+          <a:lstStyle>
+            <a:lvl1pPr algn="r">
+              <a:defRPr sz="1200"/>
+            </a:lvl1pPr>
+          </a:lstStyle>
+          <a:p>
+            <a:fld id="{BB5E49A5-4136-284D-997B-48E1D791AD67}" type="slidenum">
+              <a:rPr lang="en-US" smtClean="0"/>
+              <a:t>‹#›</a:t>
+            </a:fld>
+            <a:endParaRPr lang="en-US"/>
+          </a:p>
+        </p:txBody>
+      </p:sp>
+    </p:spTree>
+    <p:extLst>
+      <p:ext uri="{BB962C8B-B14F-4D97-AF65-F5344CB8AC3E}">
+        <p14:creationId xmlns:p14="http://schemas.microsoft.com/office/powerpoint/2010/main" val="2623252185"/>
+      </p:ext>
+    </p:extLst>
+  </p:cSld>
+  <p:clrMap bg1="lt1" tx1="dk1" bg2="lt2" tx2="dk2" accent1="accent1" accent2="accent2" accent3="accent3" accent4="accent4" accent5="accent5" accent6="accent6" hlink="hlink" folHlink="folHlink"/>
+  <p:notesStyle>
+    <a:lvl1pPr marL="0" algn="l" defTabSz="457200" rtl="0" eaLnBrk="1" latinLnBrk="0" hangingPunct="1">
+      <a:defRPr sz="1200" kern="1200">
+        <a:solidFill>
+          <a:schemeClr val="tx1"/>
+        </a:solidFill>
+        <a:latin typeface="+mn-lt"/>
+        <a:ea typeface="+mn-ea"/>
+        <a:cs typeface="+mn-cs"/>
+      </a:defRPr>
+    </a:lvl1pPr>
+    <a:lvl2pPr marL="457200" algn="l" defTabSz="457200" rtl="0" eaLnBrk="1" latinLnBrk="0" hangingPunct="1">
+      <a:defRPr sz="1200" kern="1200">
+        <a:solidFill>
+          <a:schemeClr val="tx1"/>
+        </a:solidFill>
+        <a:latin typeface="+mn-lt"/>
+        <a:ea typeface="+mn-ea"/>
+        <a:cs typeface="+mn-cs"/>
+      </a:defRPr>
+    </a:lvl2pPr>
+    <a:lvl3pPr marL="914400" algn="l" defTabSz="457200" rtl="0" eaLnBrk="1" latinLnBrk="0" hangingPunct="1">
+      <a:defRPr sz="1200" kern="1200">
+        <a:solidFill>
+          <a:schemeClr val="tx1"/>
+        </a:solidFill>
+        <a:latin typeface="+mn-lt"/>
+        <a:ea typeface="+mn-ea"/>
+        <a:cs typeface="+mn-cs"/>
+      </a:defRPr>
+    </a:lvl3pPr>
+    <a:lvl4pPr marL="1371600" algn="l" defTabSz="457200" rtl="0" eaLnBrk="1" latinLnBrk="0" hangingPunct="1">
+      <a:defRPr sz="1200" kern="1200">
+        <a:solidFill>
+          <a:schemeClr val="tx1"/>
+        </a:solidFill>
+        <a:latin typeface="+mn-lt"/>
+        <a:ea typeface="+mn-ea"/>
+        <a:cs typeface="+mn-cs"/>
+      </a:defRPr>
+    </a:lvl4pPr>
+    <a:lvl5pPr marL="1828800" algn="l" defTabSz="457200" rtl="0" eaLnBrk="1" latinLnBrk="0" hangingPunct="1">
+      <a:defRPr sz="1200" kern="1200">
+        <a:solidFill>
+          <a:schemeClr val="tx1"/>
+        </a:solidFill>
+        <a:latin typeface="+mn-lt"/>
+        <a:ea typeface="+mn-ea"/>
+        <a:cs typeface="+mn-cs"/>
+      </a:defRPr>
+    </a:lvl5pPr>
+    <a:lvl6pPr marL="2286000" algn="l" defTabSz="457200" rtl="0" eaLnBrk="1" latinLnBrk="0" hangingPunct="1">
+      <a:defRPr sz="1200" kern="1200">
+        <a:solidFill>
+          <a:schemeClr val="tx1"/>
+        </a:solidFill>
+        <a:latin typeface="+mn-lt"/>
+        <a:ea typeface="+mn-ea"/>
+        <a:cs typeface="+mn-cs"/>
+      </a:defRPr>
+    </a:lvl6pPr>
+    <a:lvl7pPr marL="2743200" algn="l" defTabSz="457200" rtl="0" eaLnBrk="1" latinLnBrk="0" hangingPunct="1">
+      <a:defRPr sz="1200" kern="1200">
+        <a:solidFill>
+          <a:schemeClr val="tx1"/>
+        </a:solidFill>
+        <a:latin typeface="+mn-lt"/>
+        <a:ea typeface="+mn-ea"/>
+        <a:cs typeface="+mn-cs"/>
+      </a:defRPr>
+    </a:lvl7pPr>
+    <a:lvl8pPr marL="3200400" algn="l" defTabSz="457200" rtl="0" eaLnBrk="1" latinLnBrk="0" hangingPunct="1">
+      <a:defRPr sz="1200" kern="1200">
+        <a:solidFill>
+          <a:schemeClr val="tx1"/>
+        </a:solidFill>
+        <a:latin typeface="+mn-lt"/>
+        <a:ea typeface="+mn-ea"/>
+        <a:cs typeface="+mn-cs"/>
+      </a:defRPr>
+    </a:lvl8pPr>
+    <a:lvl9pPr marL="3657600" algn="l" defTabSz="457200" rtl="0" eaLnBrk="1" latinLnBrk="0" hangingPunct="1">
+      <a:defRPr sz="1200" kern="1200">
+        <a:solidFill>
+          <a:schemeClr val="tx1"/>
+        </a:solidFill>
+        <a:latin typeface="+mn-lt"/>
+        <a:ea typeface="+mn-ea"/>
+        <a:cs typeface="+mn-cs"/>
+      </a:defRPr>
+    </a:lvl9pPr>
+  </p:notesStyle>
+</p:notesMaster>
+</file>
+
+<file path=ppt/notesSlides/notesSlide1.xml><?xml version="1.0" encoding="utf-8"?>
+<p:notes xmlns:a="http://schemas.openxmlformats.org/drawingml/2006/main" xmlns:p="http://schemas.openxmlformats.org/presentationml/2006/main" xmlns:r="http://schemas.openxmlformats.org/officeDocument/2006/relationships">
+  <p:cSld>
+    <p:spTree>
+      <p:nvGrpSpPr>
+        <p:cNvPr id="1" name=""/>
+        <p:cNvGrpSpPr/>
+        <p:nvPr/>
+      </p:nvGrpSpPr>
+      <p:grpSpPr>
+        <a:xfrm>
+          <a:off x="0" y="0"/>
+          <a:ext cx="0" cy="0"/>
+          <a:chOff x="0" y="0"/>
+          <a:chExt cx="0" cy="0"/>
+        </a:xfrm>
+      </p:grpSpPr>
+      <p:sp>
+        <p:nvSpPr>
+          <p:cNvPr id="2" name="Slide Image Placeholder 1"/>
+          <p:cNvSpPr>
+            <a:spLocks noGrp="1"/>
+          </p:cNvSpPr>
+          <p:nvPr>
+            <p:ph type="sldImg" idx="2"/>
+          </p:nvPr>
+        </p:nvSpPr>
+        <p:spPr/>
+      </p:sp>
+      <p:sp>
+        <p:nvSpPr>
+          <p:cNvPr id="3" name="Notes Placeholder 2"/>
+          <p:cNvSpPr>
+            <a:spLocks noGrp="1"/>
+          </p:cNvSpPr>
+          <p:nvPr>
+            <p:ph type="body" idx="3" sz="quarter"/>
+          </p:nvPr>
+        </p:nvSpPr>
+        <p:spPr/>
+        <p:txBody>
+          <a:bodyPr/>
+          <a:lstStyle/>
+          <a:p>
+            <a:r>
+              <a:t>Welcome everyone — today we're doing a practical deep-dive into GitHub Copilot for developers. This isn't a marketing talk — we're going to look under the hood at how the agent actually works, what you can customize, and walk through a real PoC we built using nothing but /plan and agent mode. By the end you'll have a concrete toolkit you can apply starting today.</a:t>
+            </a:r>
+          </a:p>
+        </p:txBody>
+      </p:sp>
+      <p:sp>
+        <p:nvSpPr>
+          <p:cNvPr id="4" name="Slide Number Placeholder 3"/>
+          <p:cNvSpPr>
+            <a:spLocks noGrp="1"/>
+          </p:cNvSpPr>
+          <p:nvPr>
+            <p:ph type="sldNum" idx="5" sz="quarter"/>
+          </p:nvPr>
+        </p:nvSpPr>
+        <p:spPr/>
+      </p:sp>
+    </p:spTree>
+  </p:cSld>
+  <p:clrMapOvr>
+    <a:masterClrMapping/>
+  </p:clrMapOvr>
+</p:notes>
+</file>
+
+<file path=ppt/notesSlides/notesSlide10.xml><?xml version="1.0" encoding="utf-8"?>
+<p:notes xmlns:a="http://schemas.openxmlformats.org/drawingml/2006/main" xmlns:p="http://schemas.openxmlformats.org/presentationml/2006/main" xmlns:r="http://schemas.openxmlformats.org/officeDocument/2006/relationships">
+  <p:cSld>
+    <p:spTree>
+      <p:nvGrpSpPr>
+        <p:cNvPr id="1" name=""/>
+        <p:cNvGrpSpPr/>
+        <p:nvPr/>
+      </p:nvGrpSpPr>
+      <p:grpSpPr>
+        <a:xfrm>
+          <a:off x="0" y="0"/>
+          <a:ext cx="0" cy="0"/>
+          <a:chOff x="0" y="0"/>
+          <a:chExt cx="0" cy="0"/>
+        </a:xfrm>
+      </p:grpSpPr>
+      <p:sp>
+        <p:nvSpPr>
+          <p:cNvPr id="2" name="Slide Image Placeholder 1"/>
+          <p:cNvSpPr>
+            <a:spLocks noGrp="1"/>
+          </p:cNvSpPr>
+          <p:nvPr>
+            <p:ph type="sldImg" idx="2"/>
+          </p:nvPr>
+        </p:nvSpPr>
+        <p:spPr/>
+      </p:sp>
+      <p:sp>
+        <p:nvSpPr>
+          <p:cNvPr id="3" name="Notes Placeholder 2"/>
+          <p:cNvSpPr>
+            <a:spLocks noGrp="1"/>
+          </p:cNvSpPr>
+          <p:nvPr>
+            <p:ph type="body" idx="3" sz="quarter"/>
+          </p:nvPr>
+        </p:nvSpPr>
+        <p:spPr/>
+        <p:txBody>
+          <a:bodyPr/>
+          <a:lstStyle/>
+          <a:p>
+            <a:r>
+              <a:t>Here's exactly what happened when we used /plan for our PoC. Six questions, six answers, six phases. Notice the specificity — it didn't just say 'build authentication', it produced a phase-by-phase breakdown with explicit technology choices: RS256 JWT, Lua atomic scripts in Redis, React 19 with TypeScript. Every subsequent Copilot action in that session referenced this plan. That's the value — it creates a shared mental model between you and the agent that persists for the entire conversation.</a:t>
+            </a:r>
+          </a:p>
+        </p:txBody>
+      </p:sp>
+      <p:sp>
+        <p:nvSpPr>
+          <p:cNvPr id="4" name="Slide Number Placeholder 3"/>
+          <p:cNvSpPr>
+            <a:spLocks noGrp="1"/>
+          </p:cNvSpPr>
+          <p:nvPr>
+            <p:ph type="sldNum" idx="5" sz="quarter"/>
+          </p:nvPr>
+        </p:nvSpPr>
+        <p:spPr/>
+      </p:sp>
+    </p:spTree>
+  </p:cSld>
+  <p:clrMapOvr>
+    <a:masterClrMapping/>
+  </p:clrMapOvr>
+</p:notes>
+</file>
+
+<file path=ppt/notesSlides/notesSlide11.xml><?xml version="1.0" encoding="utf-8"?>
+<p:notes xmlns:a="http://schemas.openxmlformats.org/drawingml/2006/main" xmlns:p="http://schemas.openxmlformats.org/presentationml/2006/main" xmlns:r="http://schemas.openxmlformats.org/officeDocument/2006/relationships">
+  <p:cSld>
+    <p:spTree>
+      <p:nvGrpSpPr>
+        <p:cNvPr id="1" name=""/>
+        <p:cNvGrpSpPr/>
+        <p:nvPr/>
+      </p:nvGrpSpPr>
+      <p:grpSpPr>
+        <a:xfrm>
+          <a:off x="0" y="0"/>
+          <a:ext cx="0" cy="0"/>
+          <a:chOff x="0" y="0"/>
+          <a:chExt cx="0" cy="0"/>
+        </a:xfrm>
+      </p:grpSpPr>
+      <p:sp>
+        <p:nvSpPr>
+          <p:cNvPr id="2" name="Slide Image Placeholder 1"/>
+          <p:cNvSpPr>
+            <a:spLocks noGrp="1"/>
+          </p:cNvSpPr>
+          <p:nvPr>
+            <p:ph type="sldImg" idx="2"/>
+          </p:nvPr>
+        </p:nvSpPr>
+        <p:spPr/>
+      </p:sp>
+      <p:sp>
+        <p:nvSpPr>
+          <p:cNvPr id="3" name="Notes Placeholder 2"/>
+          <p:cNvSpPr>
+            <a:spLocks noGrp="1"/>
+          </p:cNvSpPr>
+          <p:nvPr>
+            <p:ph type="body" idx="3" sz="quarter"/>
+          </p:nvPr>
+        </p:nvSpPr>
+        <p:spPr/>
+        <p:txBody>
+          <a:bodyPr/>
+          <a:lstStyle/>
+          <a:p>
+            <a:r>
+              <a:t>Now we get to the part I find most interesting — the customization layer. This is what separates teams using Copilot as a fancy autocomplete from teams where every developer gets consistent, project-aware, policy-enforced output.</a:t>
+            </a:r>
+          </a:p>
+        </p:txBody>
+      </p:sp>
+      <p:sp>
+        <p:nvSpPr>
+          <p:cNvPr id="4" name="Slide Number Placeholder 3"/>
+          <p:cNvSpPr>
+            <a:spLocks noGrp="1"/>
+          </p:cNvSpPr>
+          <p:nvPr>
+            <p:ph type="sldNum" idx="5" sz="quarter"/>
+          </p:nvPr>
+        </p:nvSpPr>
+        <p:spPr/>
+      </p:sp>
+    </p:spTree>
+  </p:cSld>
+  <p:clrMapOvr>
+    <a:masterClrMapping/>
+  </p:clrMapOvr>
+</p:notes>
+</file>
+
+<file path=ppt/notesSlides/notesSlide12.xml><?xml version="1.0" encoding="utf-8"?>
+<p:notes xmlns:a="http://schemas.openxmlformats.org/drawingml/2006/main" xmlns:p="http://schemas.openxmlformats.org/presentationml/2006/main" xmlns:r="http://schemas.openxmlformats.org/officeDocument/2006/relationships">
+  <p:cSld>
+    <p:spTree>
+      <p:nvGrpSpPr>
+        <p:cNvPr id="1" name=""/>
+        <p:cNvGrpSpPr/>
+        <p:nvPr/>
+      </p:nvGrpSpPr>
+      <p:grpSpPr>
+        <a:xfrm>
+          <a:off x="0" y="0"/>
+          <a:ext cx="0" cy="0"/>
+          <a:chOff x="0" y="0"/>
+          <a:chExt cx="0" cy="0"/>
+        </a:xfrm>
+      </p:grpSpPr>
+      <p:sp>
+        <p:nvSpPr>
+          <p:cNvPr id="2" name="Slide Image Placeholder 1"/>
+          <p:cNvSpPr>
+            <a:spLocks noGrp="1"/>
+          </p:cNvSpPr>
+          <p:nvPr>
+            <p:ph type="sldImg" idx="2"/>
+          </p:nvPr>
+        </p:nvSpPr>
+        <p:spPr/>
+      </p:sp>
+      <p:sp>
+        <p:nvSpPr>
+          <p:cNvPr id="3" name="Notes Placeholder 2"/>
+          <p:cNvSpPr>
+            <a:spLocks noGrp="1"/>
+          </p:cNvSpPr>
+          <p:nvPr>
+            <p:ph type="body" idx="3" sz="quarter"/>
+          </p:nvPr>
+        </p:nvSpPr>
+        <p:spPr/>
+        <p:txBody>
+          <a:bodyPr/>
+          <a:lstStyle/>
+          <a:p>
+            <a:r>
+              <a:t>There are six customization primitives and they're not interchangeable. The short version: workspace instructions are your always-on project rules that apply to everything. File instructions are scoped — either to file types or to specific task contexts. Prompts are for single reusable tasks. Skills are for multi-step workflows with bundled assets. Custom agents define specialized personas with restricted tools. And hooks are for deterministic enforcement — things the model absolutely cannot skip.</a:t>
+            </a:r>
+          </a:p>
+        </p:txBody>
+      </p:sp>
+      <p:sp>
+        <p:nvSpPr>
+          <p:cNvPr id="4" name="Slide Number Placeholder 3"/>
+          <p:cNvSpPr>
+            <a:spLocks noGrp="1"/>
+          </p:cNvSpPr>
+          <p:nvPr>
+            <p:ph type="sldNum" idx="5" sz="quarter"/>
+          </p:nvPr>
+        </p:nvSpPr>
+        <p:spPr/>
+      </p:sp>
+    </p:spTree>
+  </p:cSld>
+  <p:clrMapOvr>
+    <a:masterClrMapping/>
+  </p:clrMapOvr>
+</p:notes>
+</file>
+
+<file path=ppt/notesSlides/notesSlide13.xml><?xml version="1.0" encoding="utf-8"?>
+<p:notes xmlns:a="http://schemas.openxmlformats.org/drawingml/2006/main" xmlns:p="http://schemas.openxmlformats.org/presentationml/2006/main" xmlns:r="http://schemas.openxmlformats.org/officeDocument/2006/relationships">
+  <p:cSld>
+    <p:spTree>
+      <p:nvGrpSpPr>
+        <p:cNvPr id="1" name=""/>
+        <p:cNvGrpSpPr/>
+        <p:nvPr/>
+      </p:nvGrpSpPr>
+      <p:grpSpPr>
+        <a:xfrm>
+          <a:off x="0" y="0"/>
+          <a:ext cx="0" cy="0"/>
+          <a:chOff x="0" y="0"/>
+          <a:chExt cx="0" cy="0"/>
+        </a:xfrm>
+      </p:grpSpPr>
+      <p:sp>
+        <p:nvSpPr>
+          <p:cNvPr id="2" name="Slide Image Placeholder 1"/>
+          <p:cNvSpPr>
+            <a:spLocks noGrp="1"/>
+          </p:cNvSpPr>
+          <p:nvPr>
+            <p:ph type="sldImg" idx="2"/>
+          </p:nvPr>
+        </p:nvSpPr>
+        <p:spPr/>
+      </p:sp>
+      <p:sp>
+        <p:nvSpPr>
+          <p:cNvPr id="3" name="Notes Placeholder 2"/>
+          <p:cNvSpPr>
+            <a:spLocks noGrp="1"/>
+          </p:cNvSpPr>
+          <p:nvPr>
+            <p:ph type="body" idx="3" sz="quarter"/>
+          </p:nvPr>
+        </p:nvSpPr>
+        <p:spPr/>
+        <p:txBody>
+          <a:bodyPr/>
+          <a:lstStyle/>
+          <a:p>
+            <a:r>
+              <a:t>Here are the decision questions I ask when choosing a primitive. The most important distinction is Hooks versus Instructions. Instructions guide the agent — they're directives the model reasons with. Hooks run shell commands at lifecycle events. If you absolutely cannot afford for something to be skipped — like blocking a force push or enforcing a linter pass — use a hook. If guidance that a good model will generally follow is enough, use instructions.</a:t>
+            </a:r>
+          </a:p>
+        </p:txBody>
+      </p:sp>
+      <p:sp>
+        <p:nvSpPr>
+          <p:cNvPr id="4" name="Slide Number Placeholder 3"/>
+          <p:cNvSpPr>
+            <a:spLocks noGrp="1"/>
+          </p:cNvSpPr>
+          <p:nvPr>
+            <p:ph type="sldNum" idx="5" sz="quarter"/>
+          </p:nvPr>
+        </p:nvSpPr>
+        <p:spPr/>
+      </p:sp>
+    </p:spTree>
+  </p:cSld>
+  <p:clrMapOvr>
+    <a:masterClrMapping/>
+  </p:clrMapOvr>
+</p:notes>
+</file>
+
+<file path=ppt/notesSlides/notesSlide14.xml><?xml version="1.0" encoding="utf-8"?>
+<p:notes xmlns:a="http://schemas.openxmlformats.org/drawingml/2006/main" xmlns:p="http://schemas.openxmlformats.org/presentationml/2006/main" xmlns:r="http://schemas.openxmlformats.org/officeDocument/2006/relationships">
+  <p:cSld>
+    <p:spTree>
+      <p:nvGrpSpPr>
+        <p:cNvPr id="1" name=""/>
+        <p:cNvGrpSpPr/>
+        <p:nvPr/>
+      </p:nvGrpSpPr>
+      <p:grpSpPr>
+        <a:xfrm>
+          <a:off x="0" y="0"/>
+          <a:ext cx="0" cy="0"/>
+          <a:chOff x="0" y="0"/>
+          <a:chExt cx="0" cy="0"/>
+        </a:xfrm>
+      </p:grpSpPr>
+      <p:sp>
+        <p:nvSpPr>
+          <p:cNvPr id="2" name="Slide Image Placeholder 1"/>
+          <p:cNvSpPr>
+            <a:spLocks noGrp="1"/>
+          </p:cNvSpPr>
+          <p:nvPr>
+            <p:ph type="sldImg" idx="2"/>
+          </p:nvPr>
+        </p:nvSpPr>
+        <p:spPr/>
+      </p:sp>
+      <p:sp>
+        <p:nvSpPr>
+          <p:cNvPr id="3" name="Notes Placeholder 2"/>
+          <p:cNvSpPr>
+            <a:spLocks noGrp="1"/>
+          </p:cNvSpPr>
+          <p:nvPr>
+            <p:ph type="body" idx="3" sz="quarter"/>
+          </p:nvPr>
+        </p:nvSpPr>
+        <p:spPr/>
+        <p:txBody>
+          <a:bodyPr/>
+          <a:lstStyle/>
+          <a:p>
+            <a:r>
+              <a:t>Workspace Instructions are the most impactful customization for most teams because they apply automatically to every chat request in the workspace. Let's look at what a good one actually contains.</a:t>
+            </a:r>
+          </a:p>
+        </p:txBody>
+      </p:sp>
+      <p:sp>
+        <p:nvSpPr>
+          <p:cNvPr id="4" name="Slide Number Placeholder 3"/>
+          <p:cNvSpPr>
+            <a:spLocks noGrp="1"/>
+          </p:cNvSpPr>
+          <p:nvPr>
+            <p:ph type="sldNum" idx="5" sz="quarter"/>
+          </p:nvPr>
+        </p:nvSpPr>
+        <p:spPr/>
+      </p:sp>
+    </p:spTree>
+  </p:cSld>
+  <p:clrMapOvr>
+    <a:masterClrMapping/>
+  </p:clrMapOvr>
+</p:notes>
+</file>
+
+<file path=ppt/notesSlides/notesSlide15.xml><?xml version="1.0" encoding="utf-8"?>
+<p:notes xmlns:a="http://schemas.openxmlformats.org/drawingml/2006/main" xmlns:p="http://schemas.openxmlformats.org/presentationml/2006/main" xmlns:r="http://schemas.openxmlformats.org/officeDocument/2006/relationships">
+  <p:cSld>
+    <p:spTree>
+      <p:nvGrpSpPr>
+        <p:cNvPr id="1" name=""/>
+        <p:cNvGrpSpPr/>
+        <p:nvPr/>
+      </p:nvGrpSpPr>
+      <p:grpSpPr>
+        <a:xfrm>
+          <a:off x="0" y="0"/>
+          <a:ext cx="0" cy="0"/>
+          <a:chOff x="0" y="0"/>
+          <a:chExt cx="0" cy="0"/>
+        </a:xfrm>
+      </p:grpSpPr>
+      <p:sp>
+        <p:nvSpPr>
+          <p:cNvPr id="2" name="Slide Image Placeholder 1"/>
+          <p:cNvSpPr>
+            <a:spLocks noGrp="1"/>
+          </p:cNvSpPr>
+          <p:nvPr>
+            <p:ph type="sldImg" idx="2"/>
+          </p:nvPr>
+        </p:nvSpPr>
+        <p:spPr/>
+      </p:sp>
+      <p:sp>
+        <p:nvSpPr>
+          <p:cNvPr id="3" name="Notes Placeholder 2"/>
+          <p:cNvSpPr>
+            <a:spLocks noGrp="1"/>
+          </p:cNvSpPr>
+          <p:nvPr>
+            <p:ph type="body" idx="3" sz="quarter"/>
+          </p:nvPr>
+        </p:nvSpPr>
+        <p:spPr/>
+        <p:txBody>
+          <a:bodyPr/>
+          <a:lstStyle/>
+          <a:p>
+            <a:r>
+              <a:t>This is a typical workspace instructions file — no YAML frontmatter needed, it loads automatically for every chat request. The Build and Test section is the highest-stakes part: these are the actual commands the agent will run. Get these wrong and the agent will confidently execute the wrong thing. The Architecture section explains your structural decisions — not just what the pattern is, but why. This prevents the agent from 'helpfully' reorganizing your code into a different architecture it learned from training data.</a:t>
+            </a:r>
+          </a:p>
+        </p:txBody>
+      </p:sp>
+      <p:sp>
+        <p:nvSpPr>
+          <p:cNvPr id="4" name="Slide Number Placeholder 3"/>
+          <p:cNvSpPr>
+            <a:spLocks noGrp="1"/>
+          </p:cNvSpPr>
+          <p:nvPr>
+            <p:ph type="sldNum" idx="5" sz="quarter"/>
+          </p:nvPr>
+        </p:nvSpPr>
+        <p:spPr/>
+      </p:sp>
+    </p:spTree>
+  </p:cSld>
+  <p:clrMapOvr>
+    <a:masterClrMapping/>
+  </p:clrMapOvr>
+</p:notes>
+</file>
+
+<file path=ppt/notesSlides/notesSlide16.xml><?xml version="1.0" encoding="utf-8"?>
+<p:notes xmlns:a="http://schemas.openxmlformats.org/drawingml/2006/main" xmlns:p="http://schemas.openxmlformats.org/presentationml/2006/main" xmlns:r="http://schemas.openxmlformats.org/officeDocument/2006/relationships">
+  <p:cSld>
+    <p:spTree>
+      <p:nvGrpSpPr>
+        <p:cNvPr id="1" name=""/>
+        <p:cNvGrpSpPr/>
+        <p:nvPr/>
+      </p:nvGrpSpPr>
+      <p:grpSpPr>
+        <a:xfrm>
+          <a:off x="0" y="0"/>
+          <a:ext cx="0" cy="0"/>
+          <a:chOff x="0" y="0"/>
+          <a:chExt cx="0" cy="0"/>
+        </a:xfrm>
+      </p:grpSpPr>
+      <p:sp>
+        <p:nvSpPr>
+          <p:cNvPr id="2" name="Slide Image Placeholder 1"/>
+          <p:cNvSpPr>
+            <a:spLocks noGrp="1"/>
+          </p:cNvSpPr>
+          <p:nvPr>
+            <p:ph type="sldImg" idx="2"/>
+          </p:nvPr>
+        </p:nvSpPr>
+        <p:spPr/>
+      </p:sp>
+      <p:sp>
+        <p:nvSpPr>
+          <p:cNvPr id="3" name="Notes Placeholder 2"/>
+          <p:cNvSpPr>
+            <a:spLocks noGrp="1"/>
+          </p:cNvSpPr>
+          <p:nvPr>
+            <p:ph type="body" idx="3" sz="quarter"/>
+          </p:nvPr>
+        </p:nvSpPr>
+        <p:spPr/>
+        <p:txBody>
+          <a:bodyPr/>
+          <a:lstStyle/>
+          <a:p>
+            <a:r>
+              <a:t>Two anti-patterns I see constantly: creating both copilot-instructions.md and AGENTS.md at the same time. Copilot only uses one — pick one and delete the other. Second, putting everything in the file. A kitchen-sink instructions file is worse than a focused one because the agent deprioritizes the parts it deems less relevant. Keep it minimal — only what actually needs to be said for every task. And update it when your practices change; the agent treats stale instructions as current truth.</a:t>
+            </a:r>
+          </a:p>
+        </p:txBody>
+      </p:sp>
+      <p:sp>
+        <p:nvSpPr>
+          <p:cNvPr id="4" name="Slide Number Placeholder 3"/>
+          <p:cNvSpPr>
+            <a:spLocks noGrp="1"/>
+          </p:cNvSpPr>
+          <p:nvPr>
+            <p:ph type="sldNum" idx="5" sz="quarter"/>
+          </p:nvPr>
+        </p:nvSpPr>
+        <p:spPr/>
+      </p:sp>
+    </p:spTree>
+  </p:cSld>
+  <p:clrMapOvr>
+    <a:masterClrMapping/>
+  </p:clrMapOvr>
+</p:notes>
+</file>
+
+<file path=ppt/notesSlides/notesSlide17.xml><?xml version="1.0" encoding="utf-8"?>
+<p:notes xmlns:a="http://schemas.openxmlformats.org/drawingml/2006/main" xmlns:p="http://schemas.openxmlformats.org/presentationml/2006/main" xmlns:r="http://schemas.openxmlformats.org/officeDocument/2006/relationships">
+  <p:cSld>
+    <p:spTree>
+      <p:nvGrpSpPr>
+        <p:cNvPr id="1" name=""/>
+        <p:cNvGrpSpPr/>
+        <p:nvPr/>
+      </p:nvGrpSpPr>
+      <p:grpSpPr>
+        <a:xfrm>
+          <a:off x="0" y="0"/>
+          <a:ext cx="0" cy="0"/>
+          <a:chOff x="0" y="0"/>
+          <a:chExt cx="0" cy="0"/>
+        </a:xfrm>
+      </p:grpSpPr>
+      <p:sp>
+        <p:nvSpPr>
+          <p:cNvPr id="2" name="Slide Image Placeholder 1"/>
+          <p:cNvSpPr>
+            <a:spLocks noGrp="1"/>
+          </p:cNvSpPr>
+          <p:nvPr>
+            <p:ph type="sldImg" idx="2"/>
+          </p:nvPr>
+        </p:nvSpPr>
+        <p:spPr/>
+      </p:sp>
+      <p:sp>
+        <p:nvSpPr>
+          <p:cNvPr id="3" name="Notes Placeholder 2"/>
+          <p:cNvSpPr>
+            <a:spLocks noGrp="1"/>
+          </p:cNvSpPr>
+          <p:nvPr>
+            <p:ph type="body" idx="3" sz="quarter"/>
+          </p:nvPr>
+        </p:nvSpPr>
+        <p:spPr/>
+        <p:txBody>
+          <a:bodyPr/>
+          <a:lstStyle/>
+          <a:p>
+            <a:r>
+              <a:t>File Instructions are workspace instructions with targeting. They let you write rules that only apply when relevant files are in context, or when the agent identifies a relevant task from your description keywords.</a:t>
+            </a:r>
+          </a:p>
+        </p:txBody>
+      </p:sp>
+      <p:sp>
+        <p:nvSpPr>
+          <p:cNvPr id="4" name="Slide Number Placeholder 3"/>
+          <p:cNvSpPr>
+            <a:spLocks noGrp="1"/>
+          </p:cNvSpPr>
+          <p:nvPr>
+            <p:ph type="sldNum" idx="5" sz="quarter"/>
+          </p:nvPr>
+        </p:nvSpPr>
+        <p:spPr/>
+      </p:sp>
+    </p:spTree>
+  </p:cSld>
+  <p:clrMapOvr>
+    <a:masterClrMapping/>
+  </p:clrMapOvr>
+</p:notes>
+</file>
+
+<file path=ppt/notesSlides/notesSlide18.xml><?xml version="1.0" encoding="utf-8"?>
+<p:notes xmlns:a="http://schemas.openxmlformats.org/drawingml/2006/main" xmlns:p="http://schemas.openxmlformats.org/presentationml/2006/main" xmlns:r="http://schemas.openxmlformats.org/officeDocument/2006/relationships">
+  <p:cSld>
+    <p:spTree>
+      <p:nvGrpSpPr>
+        <p:cNvPr id="1" name=""/>
+        <p:cNvGrpSpPr/>
+        <p:nvPr/>
+      </p:nvGrpSpPr>
+      <p:grpSpPr>
+        <a:xfrm>
+          <a:off x="0" y="0"/>
+          <a:ext cx="0" cy="0"/>
+          <a:chOff x="0" y="0"/>
+          <a:chExt cx="0" cy="0"/>
+        </a:xfrm>
+      </p:grpSpPr>
+      <p:sp>
+        <p:nvSpPr>
+          <p:cNvPr id="2" name="Slide Image Placeholder 1"/>
+          <p:cNvSpPr>
+            <a:spLocks noGrp="1"/>
+          </p:cNvSpPr>
+          <p:nvPr>
+            <p:ph type="sldImg" idx="2"/>
+          </p:nvPr>
+        </p:nvSpPr>
+        <p:spPr/>
+      </p:sp>
+      <p:sp>
+        <p:nvSpPr>
+          <p:cNvPr id="3" name="Notes Placeholder 2"/>
+          <p:cNvSpPr>
+            <a:spLocks noGrp="1"/>
+          </p:cNvSpPr>
+          <p:nvPr>
+            <p:ph type="body" idx="3" sz="quarter"/>
+          </p:nvPr>
+        </p:nvSpPr>
+        <p:spPr/>
+        <p:txBody>
+          <a:bodyPr/>
+          <a:lstStyle/>
+          <a:p>
+            <a:r>
+              <a:t>The frontmatter here has two key fields: description and applyTo, controlling two different discovery modes. applyTo is a glob pattern — when any matching file is in context, this instruction auto-loads. description is for agent-discovered loading — the agent reads it to decide relevance. Write descriptions with 'Use when:' and specific domain keywords. Keyword-rich descriptions are the difference between an instruction that gets discovered and one that's ignored.</a:t>
+            </a:r>
+          </a:p>
+        </p:txBody>
+      </p:sp>
+      <p:sp>
+        <p:nvSpPr>
+          <p:cNvPr id="4" name="Slide Number Placeholder 3"/>
+          <p:cNvSpPr>
+            <a:spLocks noGrp="1"/>
+          </p:cNvSpPr>
+          <p:nvPr>
+            <p:ph type="sldNum" idx="5" sz="quarter"/>
+          </p:nvPr>
+        </p:nvSpPr>
+        <p:spPr/>
+      </p:sp>
+    </p:spTree>
+  </p:cSld>
+  <p:clrMapOvr>
+    <a:masterClrMapping/>
+  </p:clrMapOvr>
+</p:notes>
+</file>
+
+<file path=ppt/notesSlides/notesSlide19.xml><?xml version="1.0" encoding="utf-8"?>
+<p:notes xmlns:a="http://schemas.openxmlformats.org/drawingml/2006/main" xmlns:p="http://schemas.openxmlformats.org/presentationml/2006/main" xmlns:r="http://schemas.openxmlformats.org/officeDocument/2006/relationships">
+  <p:cSld>
+    <p:spTree>
+      <p:nvGrpSpPr>
+        <p:cNvPr id="1" name=""/>
+        <p:cNvGrpSpPr/>
+        <p:nvPr/>
+      </p:nvGrpSpPr>
+      <p:grpSpPr>
+        <a:xfrm>
+          <a:off x="0" y="0"/>
+          <a:ext cx="0" cy="0"/>
+          <a:chOff x="0" y="0"/>
+          <a:chExt cx="0" cy="0"/>
+        </a:xfrm>
+      </p:grpSpPr>
+      <p:sp>
+        <p:nvSpPr>
+          <p:cNvPr id="2" name="Slide Image Placeholder 1"/>
+          <p:cNvSpPr>
+            <a:spLocks noGrp="1"/>
+          </p:cNvSpPr>
+          <p:nvPr>
+            <p:ph type="sldImg" idx="2"/>
+          </p:nvPr>
+        </p:nvSpPr>
+        <p:spPr/>
+      </p:sp>
+      <p:sp>
+        <p:nvSpPr>
+          <p:cNvPr id="3" name="Notes Placeholder 2"/>
+          <p:cNvSpPr>
+            <a:spLocks noGrp="1"/>
+          </p:cNvSpPr>
+          <p:nvPr>
+            <p:ph type="body" idx="3" sz="quarter"/>
+          </p:nvPr>
+        </p:nvSpPr>
+        <p:spPr/>
+        <p:txBody>
+          <a:bodyPr/>
+          <a:lstStyle/>
+          <a:p>
+            <a:r>
+              <a:t>Four ways an instruction can load. On-demand is the most useful for task-based rules — the agent reads your description and decides. Explicit file-based loading via applyTo is great for language standards or test conventions. Manual attachment is useful when you want something available but not auto-loaded. Always-on via applyTo: '**' should be rare — if it applies to everything, put it in workspace instructions instead.</a:t>
+            </a:r>
+          </a:p>
+        </p:txBody>
+      </p:sp>
+      <p:sp>
+        <p:nvSpPr>
+          <p:cNvPr id="4" name="Slide Number Placeholder 3"/>
+          <p:cNvSpPr>
+            <a:spLocks noGrp="1"/>
+          </p:cNvSpPr>
+          <p:nvPr>
+            <p:ph type="sldNum" idx="5" sz="quarter"/>
+          </p:nvPr>
+        </p:nvSpPr>
+        <p:spPr/>
+      </p:sp>
+    </p:spTree>
+  </p:cSld>
+  <p:clrMapOvr>
+    <a:masterClrMapping/>
+  </p:clrMapOvr>
+</p:notes>
+</file>
+
+<file path=ppt/notesSlides/notesSlide2.xml><?xml version="1.0" encoding="utf-8"?>
+<p:notes xmlns:a="http://schemas.openxmlformats.org/drawingml/2006/main" xmlns:p="http://schemas.openxmlformats.org/presentationml/2006/main" xmlns:r="http://schemas.openxmlformats.org/officeDocument/2006/relationships">
+  <p:cSld>
+    <p:spTree>
+      <p:nvGrpSpPr>
+        <p:cNvPr id="1" name=""/>
+        <p:cNvGrpSpPr/>
+        <p:nvPr/>
+      </p:nvGrpSpPr>
+      <p:grpSpPr>
+        <a:xfrm>
+          <a:off x="0" y="0"/>
+          <a:ext cx="0" cy="0"/>
+          <a:chOff x="0" y="0"/>
+          <a:chExt cx="0" cy="0"/>
+        </a:xfrm>
+      </p:grpSpPr>
+      <p:sp>
+        <p:nvSpPr>
+          <p:cNvPr id="2" name="Slide Image Placeholder 1"/>
+          <p:cNvSpPr>
+            <a:spLocks noGrp="1"/>
+          </p:cNvSpPr>
+          <p:nvPr>
+            <p:ph type="sldImg" idx="2"/>
+          </p:nvPr>
+        </p:nvSpPr>
+        <p:spPr/>
+      </p:sp>
+      <p:sp>
+        <p:nvSpPr>
+          <p:cNvPr id="3" name="Notes Placeholder 2"/>
+          <p:cNvSpPr>
+            <a:spLocks noGrp="1"/>
+          </p:cNvSpPr>
+          <p:nvPr>
+            <p:ph type="body" idx="3" sz="quarter"/>
+          </p:nvPr>
+        </p:nvSpPr>
+        <p:spPr/>
+        <p:txBody>
+          <a:bodyPr/>
+          <a:lstStyle/>
+          <a:p>
+            <a:r>
+              <a:t>Here's our roadmap. We'll start with a quick overview of what Copilot actually is, then move into the built-in slash commands — especially /plan, which I want you to walk away knowing cold. Then we do deep dives into each of the six customization primitives. The back half is a real PoC walkthrough — we built an OAuth2 plus JWT auth system entirely in agent mode — and we close with best practices and a security checklist.</a:t>
+            </a:r>
+          </a:p>
+        </p:txBody>
+      </p:sp>
+      <p:sp>
+        <p:nvSpPr>
+          <p:cNvPr id="4" name="Slide Number Placeholder 3"/>
+          <p:cNvSpPr>
+            <a:spLocks noGrp="1"/>
+          </p:cNvSpPr>
+          <p:nvPr>
+            <p:ph type="sldNum" idx="5" sz="quarter"/>
+          </p:nvPr>
+        </p:nvSpPr>
+        <p:spPr/>
+      </p:sp>
+    </p:spTree>
+  </p:cSld>
+  <p:clrMapOvr>
+    <a:masterClrMapping/>
+  </p:clrMapOvr>
+</p:notes>
+</file>
+
+<file path=ppt/notesSlides/notesSlide20.xml><?xml version="1.0" encoding="utf-8"?>
+<p:notes xmlns:a="http://schemas.openxmlformats.org/drawingml/2006/main" xmlns:p="http://schemas.openxmlformats.org/presentationml/2006/main" xmlns:r="http://schemas.openxmlformats.org/officeDocument/2006/relationships">
+  <p:cSld>
+    <p:spTree>
+      <p:nvGrpSpPr>
+        <p:cNvPr id="1" name=""/>
+        <p:cNvGrpSpPr/>
+        <p:nvPr/>
+      </p:nvGrpSpPr>
+      <p:grpSpPr>
+        <a:xfrm>
+          <a:off x="0" y="0"/>
+          <a:ext cx="0" cy="0"/>
+          <a:chOff x="0" y="0"/>
+          <a:chExt cx="0" cy="0"/>
+        </a:xfrm>
+      </p:grpSpPr>
+      <p:sp>
+        <p:nvSpPr>
+          <p:cNvPr id="2" name="Slide Image Placeholder 1"/>
+          <p:cNvSpPr>
+            <a:spLocks noGrp="1"/>
+          </p:cNvSpPr>
+          <p:nvPr>
+            <p:ph type="sldImg" idx="2"/>
+          </p:nvPr>
+        </p:nvSpPr>
+        <p:spPr/>
+      </p:sp>
+      <p:sp>
+        <p:nvSpPr>
+          <p:cNvPr id="3" name="Notes Placeholder 2"/>
+          <p:cNvSpPr>
+            <a:spLocks noGrp="1"/>
+          </p:cNvSpPr>
+          <p:nvPr>
+            <p:ph type="body" idx="3" sz="quarter"/>
+          </p:nvPr>
+        </p:nvSpPr>
+        <p:spPr/>
+        <p:txBody>
+          <a:bodyPr/>
+          <a:lstStyle/>
+          <a:p>
+            <a:r>
+              <a:t>Prompts are how you package a single task — something you do repeatedly — into a slash command you can share with the whole team.</a:t>
+            </a:r>
+          </a:p>
+        </p:txBody>
+      </p:sp>
+      <p:sp>
+        <p:nvSpPr>
+          <p:cNvPr id="4" name="Slide Number Placeholder 3"/>
+          <p:cNvSpPr>
+            <a:spLocks noGrp="1"/>
+          </p:cNvSpPr>
+          <p:nvPr>
+            <p:ph type="sldNum" idx="5" sz="quarter"/>
+          </p:nvPr>
+        </p:nvSpPr>
+        <p:spPr/>
+      </p:sp>
+    </p:spTree>
+  </p:cSld>
+  <p:clrMapOvr>
+    <a:masterClrMapping/>
+  </p:clrMapOvr>
+</p:notes>
+</file>
+
+<file path=ppt/notesSlides/notesSlide21.xml><?xml version="1.0" encoding="utf-8"?>
+<p:notes xmlns:a="http://schemas.openxmlformats.org/drawingml/2006/main" xmlns:p="http://schemas.openxmlformats.org/presentationml/2006/main" xmlns:r="http://schemas.openxmlformats.org/officeDocument/2006/relationships">
+  <p:cSld>
+    <p:spTree>
+      <p:nvGrpSpPr>
+        <p:cNvPr id="1" name=""/>
+        <p:cNvGrpSpPr/>
+        <p:nvPr/>
+      </p:nvGrpSpPr>
+      <p:grpSpPr>
+        <a:xfrm>
+          <a:off x="0" y="0"/>
+          <a:ext cx="0" cy="0"/>
+          <a:chOff x="0" y="0"/>
+          <a:chExt cx="0" cy="0"/>
+        </a:xfrm>
+      </p:grpSpPr>
+      <p:sp>
+        <p:nvSpPr>
+          <p:cNvPr id="2" name="Slide Image Placeholder 1"/>
+          <p:cNvSpPr>
+            <a:spLocks noGrp="1"/>
+          </p:cNvSpPr>
+          <p:nvPr>
+            <p:ph type="sldImg" idx="2"/>
+          </p:nvPr>
+        </p:nvSpPr>
+        <p:spPr/>
+      </p:sp>
+      <p:sp>
+        <p:nvSpPr>
+          <p:cNvPr id="3" name="Notes Placeholder 2"/>
+          <p:cNvSpPr>
+            <a:spLocks noGrp="1"/>
+          </p:cNvSpPr>
+          <p:nvPr>
+            <p:ph type="body" idx="3" sz="quarter"/>
+          </p:nvPr>
+        </p:nvSpPr>
+        <p:spPr/>
+        <p:txBody>
+          <a:bodyPr/>
+          <a:lstStyle/>
+          <a:p>
+            <a:r>
+              <a:t>Here's a generate-tests prompt. The agent field sets the execution mode — 'agent' means it can use tools to read files, edit files, search. The tools field restricts what tools are available — principle of least privilege in practice. The model field lets you pin a specific model for this prompt. And the body uses a relative Markdown link to the tests folder — the agent will actually read those files to understand your test patterns before generating new ones.</a:t>
+            </a:r>
+          </a:p>
+        </p:txBody>
+      </p:sp>
+      <p:sp>
+        <p:nvSpPr>
+          <p:cNvPr id="4" name="Slide Number Placeholder 3"/>
+          <p:cNvSpPr>
+            <a:spLocks noGrp="1"/>
+          </p:cNvSpPr>
+          <p:nvPr>
+            <p:ph type="sldNum" idx="5" sz="quarter"/>
+          </p:nvPr>
+        </p:nvSpPr>
+        <p:spPr/>
+      </p:sp>
+    </p:spTree>
+  </p:cSld>
+  <p:clrMapOvr>
+    <a:masterClrMapping/>
+  </p:clrMapOvr>
+</p:notes>
+</file>
+
+<file path=ppt/notesSlides/notesSlide22.xml><?xml version="1.0" encoding="utf-8"?>
+<p:notes xmlns:a="http://schemas.openxmlformats.org/drawingml/2006/main" xmlns:p="http://schemas.openxmlformats.org/presentationml/2006/main" xmlns:r="http://schemas.openxmlformats.org/officeDocument/2006/relationships">
+  <p:cSld>
+    <p:spTree>
+      <p:nvGrpSpPr>
+        <p:cNvPr id="1" name=""/>
+        <p:cNvGrpSpPr/>
+        <p:nvPr/>
+      </p:nvGrpSpPr>
+      <p:grpSpPr>
+        <a:xfrm>
+          <a:off x="0" y="0"/>
+          <a:ext cx="0" cy="0"/>
+          <a:chOff x="0" y="0"/>
+          <a:chExt cx="0" cy="0"/>
+        </a:xfrm>
+      </p:grpSpPr>
+      <p:sp>
+        <p:nvSpPr>
+          <p:cNvPr id="2" name="Slide Image Placeholder 1"/>
+          <p:cNvSpPr>
+            <a:spLocks noGrp="1"/>
+          </p:cNvSpPr>
+          <p:nvPr>
+            <p:ph type="sldImg" idx="2"/>
+          </p:nvPr>
+        </p:nvSpPr>
+        <p:spPr/>
+      </p:sp>
+      <p:sp>
+        <p:nvSpPr>
+          <p:cNvPr id="3" name="Notes Placeholder 2"/>
+          <p:cNvSpPr>
+            <a:spLocks noGrp="1"/>
+          </p:cNvSpPr>
+          <p:nvPr>
+            <p:ph type="body" idx="3" sz="quarter"/>
+          </p:nvPr>
+        </p:nvSpPr>
+        <p:spPr/>
+        <p:txBody>
+          <a:bodyPr/>
+          <a:lstStyle/>
+          <a:p>
+            <a:r>
+              <a:t>The main principle for prompts is single-task focus. A prompt that says 'create and test and deploy' is three separate prompts — split them. The other thing that trips people up is vague descriptions. Write descriptions like internal documentation: 'Use when you need to generate test cases for a class or method.' Also, use relative Markdown links to reference relevant files; don't hardcode paths that break on other machines.</a:t>
+            </a:r>
+          </a:p>
+        </p:txBody>
+      </p:sp>
+      <p:sp>
+        <p:nvSpPr>
+          <p:cNvPr id="4" name="Slide Number Placeholder 3"/>
+          <p:cNvSpPr>
+            <a:spLocks noGrp="1"/>
+          </p:cNvSpPr>
+          <p:nvPr>
+            <p:ph type="sldNum" idx="5" sz="quarter"/>
+          </p:nvPr>
+        </p:nvSpPr>
+        <p:spPr/>
+      </p:sp>
+    </p:spTree>
+  </p:cSld>
+  <p:clrMapOvr>
+    <a:masterClrMapping/>
+  </p:clrMapOvr>
+</p:notes>
+</file>
+
+<file path=ppt/notesSlides/notesSlide23.xml><?xml version="1.0" encoding="utf-8"?>
+<p:notes xmlns:a="http://schemas.openxmlformats.org/drawingml/2006/main" xmlns:p="http://schemas.openxmlformats.org/presentationml/2006/main" xmlns:r="http://schemas.openxmlformats.org/officeDocument/2006/relationships">
+  <p:cSld>
+    <p:spTree>
+      <p:nvGrpSpPr>
+        <p:cNvPr id="1" name=""/>
+        <p:cNvGrpSpPr/>
+        <p:nvPr/>
+      </p:nvGrpSpPr>
+      <p:grpSpPr>
+        <a:xfrm>
+          <a:off x="0" y="0"/>
+          <a:ext cx="0" cy="0"/>
+          <a:chOff x="0" y="0"/>
+          <a:chExt cx="0" cy="0"/>
+        </a:xfrm>
+      </p:grpSpPr>
+      <p:sp>
+        <p:nvSpPr>
+          <p:cNvPr id="2" name="Slide Image Placeholder 1"/>
+          <p:cNvSpPr>
+            <a:spLocks noGrp="1"/>
+          </p:cNvSpPr>
+          <p:nvPr>
+            <p:ph type="sldImg" idx="2"/>
+          </p:nvPr>
+        </p:nvSpPr>
+        <p:spPr/>
+      </p:sp>
+      <p:sp>
+        <p:nvSpPr>
+          <p:cNvPr id="3" name="Notes Placeholder 2"/>
+          <p:cNvSpPr>
+            <a:spLocks noGrp="1"/>
+          </p:cNvSpPr>
+          <p:nvPr>
+            <p:ph type="body" idx="3" sz="quarter"/>
+          </p:nvPr>
+        </p:nvSpPr>
+        <p:spPr/>
+        <p:txBody>
+          <a:bodyPr/>
+          <a:lstStyle/>
+          <a:p>
+            <a:r>
+              <a:t>Skills are for the workflows that are too complex for a single prompt — multiple steps, supporting scripts, reference documents, boilerplate assets. If you've got all that in a repeated workflow, make it a skill.</a:t>
+            </a:r>
+          </a:p>
+        </p:txBody>
+      </p:sp>
+      <p:sp>
+        <p:nvSpPr>
+          <p:cNvPr id="4" name="Slide Number Placeholder 3"/>
+          <p:cNvSpPr>
+            <a:spLocks noGrp="1"/>
+          </p:cNvSpPr>
+          <p:nvPr>
+            <p:ph type="sldNum" idx="5" sz="quarter"/>
+          </p:nvPr>
+        </p:nvSpPr>
+        <p:spPr/>
+      </p:sp>
+    </p:spTree>
+  </p:cSld>
+  <p:clrMapOvr>
+    <a:masterClrMapping/>
+  </p:clrMapOvr>
+</p:notes>
+</file>
+
+<file path=ppt/notesSlides/notesSlide24.xml><?xml version="1.0" encoding="utf-8"?>
+<p:notes xmlns:a="http://schemas.openxmlformats.org/drawingml/2006/main" xmlns:p="http://schemas.openxmlformats.org/presentationml/2006/main" xmlns:r="http://schemas.openxmlformats.org/officeDocument/2006/relationships">
+  <p:cSld>
+    <p:spTree>
+      <p:nvGrpSpPr>
+        <p:cNvPr id="1" name=""/>
+        <p:cNvGrpSpPr/>
+        <p:nvPr/>
+      </p:nvGrpSpPr>
+      <p:grpSpPr>
+        <a:xfrm>
+          <a:off x="0" y="0"/>
+          <a:ext cx="0" cy="0"/>
+          <a:chOff x="0" y="0"/>
+          <a:chExt cx="0" cy="0"/>
+        </a:xfrm>
+      </p:grpSpPr>
+      <p:sp>
+        <p:nvSpPr>
+          <p:cNvPr id="2" name="Slide Image Placeholder 1"/>
+          <p:cNvSpPr>
+            <a:spLocks noGrp="1"/>
+          </p:cNvSpPr>
+          <p:nvPr>
+            <p:ph type="sldImg" idx="2"/>
+          </p:nvPr>
+        </p:nvSpPr>
+        <p:spPr/>
+      </p:sp>
+      <p:sp>
+        <p:nvSpPr>
+          <p:cNvPr id="3" name="Notes Placeholder 2"/>
+          <p:cNvSpPr>
+            <a:spLocks noGrp="1"/>
+          </p:cNvSpPr>
+          <p:nvPr>
+            <p:ph type="body" idx="3" sz="quarter"/>
+          </p:nvPr>
+        </p:nvSpPr>
+        <p:spPr/>
+        <p:txBody>
+          <a:bodyPr/>
+          <a:lstStyle/>
+          <a:p>
+            <a:r>
+              <a:t>A critical gotcha: the folder name must exactly match the name field in SKILL.md. If they don't match, the skill silently fails — no error, it just never loads. The description field has two stages: first ~100 tokens for discovery, then the full body loads when triggered. So your first two sentences need to be highly keyword-rich. user-invocable controls whether it appears as a slash command in the picker.</a:t>
+            </a:r>
+          </a:p>
+        </p:txBody>
+      </p:sp>
+      <p:sp>
+        <p:nvSpPr>
+          <p:cNvPr id="4" name="Slide Number Placeholder 3"/>
+          <p:cNvSpPr>
+            <a:spLocks noGrp="1"/>
+          </p:cNvSpPr>
+          <p:nvPr>
+            <p:ph type="sldNum" idx="5" sz="quarter"/>
+          </p:nvPr>
+        </p:nvSpPr>
+        <p:spPr/>
+      </p:sp>
+    </p:spTree>
+  </p:cSld>
+  <p:clrMapOvr>
+    <a:masterClrMapping/>
+  </p:clrMapOvr>
+</p:notes>
+</file>
+
+<file path=ppt/notesSlides/notesSlide25.xml><?xml version="1.0" encoding="utf-8"?>
+<p:notes xmlns:a="http://schemas.openxmlformats.org/drawingml/2006/main" xmlns:p="http://schemas.openxmlformats.org/presentationml/2006/main" xmlns:r="http://schemas.openxmlformats.org/officeDocument/2006/relationships">
+  <p:cSld>
+    <p:spTree>
+      <p:nvGrpSpPr>
+        <p:cNvPr id="1" name=""/>
+        <p:cNvGrpSpPr/>
+        <p:nvPr/>
+      </p:nvGrpSpPr>
+      <p:grpSpPr>
+        <a:xfrm>
+          <a:off x="0" y="0"/>
+          <a:ext cx="0" cy="0"/>
+          <a:chOff x="0" y="0"/>
+          <a:chExt cx="0" cy="0"/>
+        </a:xfrm>
+      </p:grpSpPr>
+      <p:sp>
+        <p:nvSpPr>
+          <p:cNvPr id="2" name="Slide Image Placeholder 1"/>
+          <p:cNvSpPr>
+            <a:spLocks noGrp="1"/>
+          </p:cNvSpPr>
+          <p:nvPr>
+            <p:ph type="sldImg" idx="2"/>
+          </p:nvPr>
+        </p:nvSpPr>
+        <p:spPr/>
+      </p:sp>
+      <p:sp>
+        <p:nvSpPr>
+          <p:cNvPr id="3" name="Notes Placeholder 2"/>
+          <p:cNvSpPr>
+            <a:spLocks noGrp="1"/>
+          </p:cNvSpPr>
+          <p:nvPr>
+            <p:ph type="body" idx="3" sz="quarter"/>
+          </p:nvPr>
+        </p:nvSpPr>
+        <p:spPr/>
+        <p:txBody>
+          <a:bodyPr/>
+          <a:lstStyle/>
+          <a:p>
+            <a:r>
+              <a:t>The folder structure matters because of progressive loading. The agent doesn't load everything at once — it reads the SKILL.md body first, then loads additional files only when they're explicitly referenced. This keeps the context window lean. Keep SKILL.md under 500 lines and move detailed reference content into a references/ subdirectory with relative links. The agent only pays the context cost of files it actually needs for that specific invocation.</a:t>
+            </a:r>
+          </a:p>
+        </p:txBody>
+      </p:sp>
+      <p:sp>
+        <p:nvSpPr>
+          <p:cNvPr id="4" name="Slide Number Placeholder 3"/>
+          <p:cNvSpPr>
+            <a:spLocks noGrp="1"/>
+          </p:cNvSpPr>
+          <p:nvPr>
+            <p:ph type="sldNum" idx="5" sz="quarter"/>
+          </p:nvPr>
+        </p:nvSpPr>
+        <p:spPr/>
+      </p:sp>
+    </p:spTree>
+  </p:cSld>
+  <p:clrMapOvr>
+    <a:masterClrMapping/>
+  </p:clrMapOvr>
+</p:notes>
+</file>
+
+<file path=ppt/notesSlides/notesSlide26.xml><?xml version="1.0" encoding="utf-8"?>
+<p:notes xmlns:a="http://schemas.openxmlformats.org/drawingml/2006/main" xmlns:p="http://schemas.openxmlformats.org/presentationml/2006/main" xmlns:r="http://schemas.openxmlformats.org/officeDocument/2006/relationships">
+  <p:cSld>
+    <p:spTree>
+      <p:nvGrpSpPr>
+        <p:cNvPr id="1" name=""/>
+        <p:cNvGrpSpPr/>
+        <p:nvPr/>
+      </p:nvGrpSpPr>
+      <p:grpSpPr>
+        <a:xfrm>
+          <a:off x="0" y="0"/>
+          <a:ext cx="0" cy="0"/>
+          <a:chOff x="0" y="0"/>
+          <a:chExt cx="0" cy="0"/>
+        </a:xfrm>
+      </p:grpSpPr>
+      <p:sp>
+        <p:nvSpPr>
+          <p:cNvPr id="2" name="Slide Image Placeholder 1"/>
+          <p:cNvSpPr>
+            <a:spLocks noGrp="1"/>
+          </p:cNvSpPr>
+          <p:nvPr>
+            <p:ph type="sldImg" idx="2"/>
+          </p:nvPr>
+        </p:nvSpPr>
+        <p:spPr/>
+      </p:sp>
+      <p:sp>
+        <p:nvSpPr>
+          <p:cNvPr id="3" name="Notes Placeholder 2"/>
+          <p:cNvSpPr>
+            <a:spLocks noGrp="1"/>
+          </p:cNvSpPr>
+          <p:nvPr>
+            <p:ph type="body" idx="3" sz="quarter"/>
+          </p:nvPr>
+        </p:nvSpPr>
+        <p:spPr/>
+        <p:txBody>
+          <a:bodyPr/>
+          <a:lstStyle/>
+          <a:p>
+            <a:r>
+              <a:t>Custom agents are where you create specialized personas — a security reviewer who can't edit files, a deployment agent with restricted shell access, a documentation writer with read-only context. The tool restriction mechanism is what makes this powerful.</a:t>
+            </a:r>
+          </a:p>
+        </p:txBody>
+      </p:sp>
+      <p:sp>
+        <p:nvSpPr>
+          <p:cNvPr id="4" name="Slide Number Placeholder 3"/>
+          <p:cNvSpPr>
+            <a:spLocks noGrp="1"/>
+          </p:cNvSpPr>
+          <p:nvPr>
+            <p:ph type="sldNum" idx="5" sz="quarter"/>
+          </p:nvPr>
+        </p:nvSpPr>
+        <p:spPr/>
+      </p:sp>
+    </p:spTree>
+  </p:cSld>
+  <p:clrMapOvr>
+    <a:masterClrMapping/>
+  </p:clrMapOvr>
+</p:notes>
+</file>
+
+<file path=ppt/notesSlides/notesSlide27.xml><?xml version="1.0" encoding="utf-8"?>
+<p:notes xmlns:a="http://schemas.openxmlformats.org/drawingml/2006/main" xmlns:p="http://schemas.openxmlformats.org/presentationml/2006/main" xmlns:r="http://schemas.openxmlformats.org/officeDocument/2006/relationships">
+  <p:cSld>
+    <p:spTree>
+      <p:nvGrpSpPr>
+        <p:cNvPr id="1" name=""/>
+        <p:cNvGrpSpPr/>
+        <p:nvPr/>
+      </p:nvGrpSpPr>
+      <p:grpSpPr>
+        <a:xfrm>
+          <a:off x="0" y="0"/>
+          <a:ext cx="0" cy="0"/>
+          <a:chOff x="0" y="0"/>
+          <a:chExt cx="0" cy="0"/>
+        </a:xfrm>
+      </p:grpSpPr>
+      <p:sp>
+        <p:nvSpPr>
+          <p:cNvPr id="2" name="Slide Image Placeholder 1"/>
+          <p:cNvSpPr>
+            <a:spLocks noGrp="1"/>
+          </p:cNvSpPr>
+          <p:nvPr>
+            <p:ph type="sldImg" idx="2"/>
+          </p:nvPr>
+        </p:nvSpPr>
+        <p:spPr/>
+      </p:sp>
+      <p:sp>
+        <p:nvSpPr>
+          <p:cNvPr id="3" name="Notes Placeholder 2"/>
+          <p:cNvSpPr>
+            <a:spLocks noGrp="1"/>
+          </p:cNvSpPr>
+          <p:nvPr>
+            <p:ph type="body" idx="3" sz="quarter"/>
+          </p:nvPr>
+        </p:nvSpPr>
+        <p:spPr/>
+        <p:txBody>
+          <a:bodyPr/>
+          <a:lstStyle/>
+          <a:p>
+            <a:r>
+              <a:t>The description field is doubly important for custom agents — it's the discovery surface for both the user agent picker and for parent agents that might delegate to this agent as a subagent. Write it with 'Use when:' and specific trigger keywords. The Constraints section in the body is critical — explicit DO NOT rules are more reliable than hoping the persona statement implies them. And agents: [] prevents this agent from spinning up subagents, keeping focused agents focused.</a:t>
+            </a:r>
+          </a:p>
+        </p:txBody>
+      </p:sp>
+      <p:sp>
+        <p:nvSpPr>
+          <p:cNvPr id="4" name="Slide Number Placeholder 3"/>
+          <p:cNvSpPr>
+            <a:spLocks noGrp="1"/>
+          </p:cNvSpPr>
+          <p:nvPr>
+            <p:ph type="sldNum" idx="5" sz="quarter"/>
+          </p:nvPr>
+        </p:nvSpPr>
+        <p:spPr/>
+      </p:sp>
+    </p:spTree>
+  </p:cSld>
+  <p:clrMapOvr>
+    <a:masterClrMapping/>
+  </p:clrMapOvr>
+</p:notes>
+</file>
+
+<file path=ppt/notesSlides/notesSlide28.xml><?xml version="1.0" encoding="utf-8"?>
+<p:notes xmlns:a="http://schemas.openxmlformats.org/drawingml/2006/main" xmlns:p="http://schemas.openxmlformats.org/presentationml/2006/main" xmlns:r="http://schemas.openxmlformats.org/officeDocument/2006/relationships">
+  <p:cSld>
+    <p:spTree>
+      <p:nvGrpSpPr>
+        <p:cNvPr id="1" name=""/>
+        <p:cNvGrpSpPr/>
+        <p:nvPr/>
+      </p:nvGrpSpPr>
+      <p:grpSpPr>
+        <a:xfrm>
+          <a:off x="0" y="0"/>
+          <a:ext cx="0" cy="0"/>
+          <a:chOff x="0" y="0"/>
+          <a:chExt cx="0" cy="0"/>
+        </a:xfrm>
+      </p:grpSpPr>
+      <p:sp>
+        <p:nvSpPr>
+          <p:cNvPr id="2" name="Slide Image Placeholder 1"/>
+          <p:cNvSpPr>
+            <a:spLocks noGrp="1"/>
+          </p:cNvSpPr>
+          <p:nvPr>
+            <p:ph type="sldImg" idx="2"/>
+          </p:nvPr>
+        </p:nvSpPr>
+        <p:spPr/>
+      </p:sp>
+      <p:sp>
+        <p:nvSpPr>
+          <p:cNvPr id="3" name="Notes Placeholder 2"/>
+          <p:cNvSpPr>
+            <a:spLocks noGrp="1"/>
+          </p:cNvSpPr>
+          <p:nvPr>
+            <p:ph type="body" idx="3" sz="quarter"/>
+          </p:nvPr>
+        </p:nvSpPr>
+        <p:spPr/>
+        <p:txBody>
+          <a:bodyPr/>
+          <a:lstStyle/>
+          <a:p>
+            <a:r>
+              <a:t>Tool aliases are how you express the principle of least privilege in agent definitions. A code reviewer only needs read and search. A documentation generator only needs read and edit. An orchestrator needs agent to delegate to subagents. The empty array [] gives a purely conversational agent with no workspace access — useful for Q&amp;A agents where you want to be certain it can't touch the filesystem. If you omit tools entirely, the agent gets all defaults, which is wrong for specialized agents.</a:t>
+            </a:r>
+          </a:p>
+        </p:txBody>
+      </p:sp>
+      <p:sp>
+        <p:nvSpPr>
+          <p:cNvPr id="4" name="Slide Number Placeholder 3"/>
+          <p:cNvSpPr>
+            <a:spLocks noGrp="1"/>
+          </p:cNvSpPr>
+          <p:nvPr>
+            <p:ph type="sldNum" idx="5" sz="quarter"/>
+          </p:nvPr>
+        </p:nvSpPr>
+        <p:spPr/>
+      </p:sp>
+    </p:spTree>
+  </p:cSld>
+  <p:clrMapOvr>
+    <a:masterClrMapping/>
+  </p:clrMapOvr>
+</p:notes>
+</file>
+
+<file path=ppt/notesSlides/notesSlide29.xml><?xml version="1.0" encoding="utf-8"?>
+<p:notes xmlns:a="http://schemas.openxmlformats.org/drawingml/2006/main" xmlns:p="http://schemas.openxmlformats.org/presentationml/2006/main" xmlns:r="http://schemas.openxmlformats.org/officeDocument/2006/relationships">
+  <p:cSld>
+    <p:spTree>
+      <p:nvGrpSpPr>
+        <p:cNvPr id="1" name=""/>
+        <p:cNvGrpSpPr/>
+        <p:nvPr/>
+      </p:nvGrpSpPr>
+      <p:grpSpPr>
+        <a:xfrm>
+          <a:off x="0" y="0"/>
+          <a:ext cx="0" cy="0"/>
+          <a:chOff x="0" y="0"/>
+          <a:chExt cx="0" cy="0"/>
+        </a:xfrm>
+      </p:grpSpPr>
+      <p:sp>
+        <p:nvSpPr>
+          <p:cNvPr id="2" name="Slide Image Placeholder 1"/>
+          <p:cNvSpPr>
+            <a:spLocks noGrp="1"/>
+          </p:cNvSpPr>
+          <p:nvPr>
+            <p:ph type="sldImg" idx="2"/>
+          </p:nvPr>
+        </p:nvSpPr>
+        <p:spPr/>
+      </p:sp>
+      <p:sp>
+        <p:nvSpPr>
+          <p:cNvPr id="3" name="Notes Placeholder 2"/>
+          <p:cNvSpPr>
+            <a:spLocks noGrp="1"/>
+          </p:cNvSpPr>
+          <p:nvPr>
+            <p:ph type="body" idx="3" sz="quarter"/>
+          </p:nvPr>
+        </p:nvSpPr>
+        <p:spPr/>
+        <p:txBody>
+          <a:bodyPr/>
+          <a:lstStyle/>
+          <a:p>
+            <a:r>
+              <a:t>Hooks are the most powerful and least-used customization primitive. They're the one mechanism that provides deterministic enforcement — the shell command runs regardless of what the model decides, because the hook runs in your terminal, not inside the model.</a:t>
+            </a:r>
+          </a:p>
+        </p:txBody>
+      </p:sp>
+      <p:sp>
+        <p:nvSpPr>
+          <p:cNvPr id="4" name="Slide Number Placeholder 3"/>
+          <p:cNvSpPr>
+            <a:spLocks noGrp="1"/>
+          </p:cNvSpPr>
+          <p:nvPr>
+            <p:ph type="sldNum" idx="5" sz="quarter"/>
+          </p:nvPr>
+        </p:nvSpPr>
+        <p:spPr/>
+      </p:sp>
+    </p:spTree>
+  </p:cSld>
+  <p:clrMapOvr>
+    <a:masterClrMapping/>
+  </p:clrMapOvr>
+</p:notes>
+</file>
+
+<file path=ppt/notesSlides/notesSlide3.xml><?xml version="1.0" encoding="utf-8"?>
+<p:notes xmlns:a="http://schemas.openxmlformats.org/drawingml/2006/main" xmlns:p="http://schemas.openxmlformats.org/presentationml/2006/main" xmlns:r="http://schemas.openxmlformats.org/officeDocument/2006/relationships">
+  <p:cSld>
+    <p:spTree>
+      <p:nvGrpSpPr>
+        <p:cNvPr id="1" name=""/>
+        <p:cNvGrpSpPr/>
+        <p:nvPr/>
+      </p:nvGrpSpPr>
+      <p:grpSpPr>
+        <a:xfrm>
+          <a:off x="0" y="0"/>
+          <a:ext cx="0" cy="0"/>
+          <a:chOff x="0" y="0"/>
+          <a:chExt cx="0" cy="0"/>
+        </a:xfrm>
+      </p:grpSpPr>
+      <p:sp>
+        <p:nvSpPr>
+          <p:cNvPr id="2" name="Slide Image Placeholder 1"/>
+          <p:cNvSpPr>
+            <a:spLocks noGrp="1"/>
+          </p:cNvSpPr>
+          <p:nvPr>
+            <p:ph type="sldImg" idx="2"/>
+          </p:nvPr>
+        </p:nvSpPr>
+        <p:spPr/>
+      </p:sp>
+      <p:sp>
+        <p:nvSpPr>
+          <p:cNvPr id="3" name="Notes Placeholder 2"/>
+          <p:cNvSpPr>
+            <a:spLocks noGrp="1"/>
+          </p:cNvSpPr>
+          <p:nvPr>
+            <p:ph type="body" idx="3" sz="quarter"/>
+          </p:nvPr>
+        </p:nvSpPr>
+        <p:spPr/>
+        <p:txBody>
+          <a:bodyPr/>
+          <a:lstStyle/>
+          <a:p>
+            <a:r>
+              <a:t>Let's start with the basics. If you've used Copilot for inline completions, you've only seen a small part of what it can do. The agent mode in Copilot Chat is a fundamentally different experience — it plans, executes, reads files, runs tests, and loops until it's done.</a:t>
+            </a:r>
+          </a:p>
+        </p:txBody>
+      </p:sp>
+      <p:sp>
+        <p:nvSpPr>
+          <p:cNvPr id="4" name="Slide Number Placeholder 3"/>
+          <p:cNvSpPr>
+            <a:spLocks noGrp="1"/>
+          </p:cNvSpPr>
+          <p:nvPr>
+            <p:ph type="sldNum" idx="5" sz="quarter"/>
+          </p:nvPr>
+        </p:nvSpPr>
+        <p:spPr/>
+      </p:sp>
+    </p:spTree>
+  </p:cSld>
+  <p:clrMapOvr>
+    <a:masterClrMapping/>
+  </p:clrMapOvr>
+</p:notes>
+</file>
+
+<file path=ppt/notesSlides/notesSlide30.xml><?xml version="1.0" encoding="utf-8"?>
+<p:notes xmlns:a="http://schemas.openxmlformats.org/drawingml/2006/main" xmlns:p="http://schemas.openxmlformats.org/presentationml/2006/main" xmlns:r="http://schemas.openxmlformats.org/officeDocument/2006/relationships">
+  <p:cSld>
+    <p:spTree>
+      <p:nvGrpSpPr>
+        <p:cNvPr id="1" name=""/>
+        <p:cNvGrpSpPr/>
+        <p:nvPr/>
+      </p:nvGrpSpPr>
+      <p:grpSpPr>
+        <a:xfrm>
+          <a:off x="0" y="0"/>
+          <a:ext cx="0" cy="0"/>
+          <a:chOff x="0" y="0"/>
+          <a:chExt cx="0" cy="0"/>
+        </a:xfrm>
+      </p:grpSpPr>
+      <p:sp>
+        <p:nvSpPr>
+          <p:cNvPr id="2" name="Slide Image Placeholder 1"/>
+          <p:cNvSpPr>
+            <a:spLocks noGrp="1"/>
+          </p:cNvSpPr>
+          <p:nvPr>
+            <p:ph type="sldImg" idx="2"/>
+          </p:nvPr>
+        </p:nvSpPr>
+        <p:spPr/>
+      </p:sp>
+      <p:sp>
+        <p:nvSpPr>
+          <p:cNvPr id="3" name="Notes Placeholder 2"/>
+          <p:cNvSpPr>
+            <a:spLocks noGrp="1"/>
+          </p:cNvSpPr>
+          <p:nvPr>
+            <p:ph type="body" idx="3" sz="quarter"/>
+          </p:nvPr>
+        </p:nvSpPr>
+        <p:spPr/>
+        <p:txBody>
+          <a:bodyPr/>
+          <a:lstStyle/>
+          <a:p>
+            <a:r>
+              <a:t>Here's the anatomy of a hook configuration. The JSON is simple: a hooks object with lifecycle event names as keys. Each event has an array of hook definitions. The important detail is the timeout field — hooks are synchronous and block the agent until they complete or time out. Keep your hooks fast, under 5 seconds. The windows field provides a PowerShell equivalent on Windows — otherwise your hook works on CI but breaks for Windows developers.</a:t>
+            </a:r>
+          </a:p>
+        </p:txBody>
+      </p:sp>
+      <p:sp>
+        <p:nvSpPr>
+          <p:cNvPr id="4" name="Slide Number Placeholder 3"/>
+          <p:cNvSpPr>
+            <a:spLocks noGrp="1"/>
+          </p:cNvSpPr>
+          <p:nvPr>
+            <p:ph type="sldNum" idx="5" sz="quarter"/>
+          </p:nvPr>
+        </p:nvSpPr>
+        <p:spPr/>
+      </p:sp>
+    </p:spTree>
+  </p:cSld>
+  <p:clrMapOvr>
+    <a:masterClrMapping/>
+  </p:clrMapOvr>
+</p:notes>
+</file>
+
+<file path=ppt/notesSlides/notesSlide31.xml><?xml version="1.0" encoding="utf-8"?>
+<p:notes xmlns:a="http://schemas.openxmlformats.org/drawingml/2006/main" xmlns:p="http://schemas.openxmlformats.org/presentationml/2006/main" xmlns:r="http://schemas.openxmlformats.org/officeDocument/2006/relationships">
+  <p:cSld>
+    <p:spTree>
+      <p:nvGrpSpPr>
+        <p:cNvPr id="1" name=""/>
+        <p:cNvGrpSpPr/>
+        <p:nvPr/>
+      </p:nvGrpSpPr>
+      <p:grpSpPr>
+        <a:xfrm>
+          <a:off x="0" y="0"/>
+          <a:ext cx="0" cy="0"/>
+          <a:chOff x="0" y="0"/>
+          <a:chExt cx="0" cy="0"/>
+        </a:xfrm>
+      </p:grpSpPr>
+      <p:sp>
+        <p:nvSpPr>
+          <p:cNvPr id="2" name="Slide Image Placeholder 1"/>
+          <p:cNvSpPr>
+            <a:spLocks noGrp="1"/>
+          </p:cNvSpPr>
+          <p:nvPr>
+            <p:ph type="sldImg" idx="2"/>
+          </p:nvPr>
+        </p:nvSpPr>
+        <p:spPr/>
+      </p:sp>
+      <p:sp>
+        <p:nvSpPr>
+          <p:cNvPr id="3" name="Notes Placeholder 2"/>
+          <p:cNvSpPr>
+            <a:spLocks noGrp="1"/>
+          </p:cNvSpPr>
+          <p:nvPr>
+            <p:ph type="body" idx="3" sz="quarter"/>
+          </p:nvPr>
+        </p:nvSpPr>
+        <p:spPr/>
+        <p:txBody>
+          <a:bodyPr/>
+          <a:lstStyle/>
+          <a:p>
+            <a:r>
+              <a:t>The I/O contract is how your script actually controls the agent. The agent passes JSON on stdin describing what it's about to do — tool name and input. Your script decides what to do and writes a JSON response to stdout. The permissionDecision field is the key: deny blocks the tool call entirely, ask pauses and prompts the user for approval, allow proceeds. This is the mechanism for policies like 'never force push without approval' that actually work regardless of model output.</a:t>
+            </a:r>
+          </a:p>
+        </p:txBody>
+      </p:sp>
+      <p:sp>
+        <p:nvSpPr>
+          <p:cNvPr id="4" name="Slide Number Placeholder 3"/>
+          <p:cNvSpPr>
+            <a:spLocks noGrp="1"/>
+          </p:cNvSpPr>
+          <p:nvPr>
+            <p:ph type="sldNum" idx="5" sz="quarter"/>
+          </p:nvPr>
+        </p:nvSpPr>
+        <p:spPr/>
+      </p:sp>
+    </p:spTree>
+  </p:cSld>
+  <p:clrMapOvr>
+    <a:masterClrMapping/>
+  </p:clrMapOvr>
+</p:notes>
+</file>
+
+<file path=ppt/notesSlides/notesSlide32.xml><?xml version="1.0" encoding="utf-8"?>
+<p:notes xmlns:a="http://schemas.openxmlformats.org/drawingml/2006/main" xmlns:p="http://schemas.openxmlformats.org/presentationml/2006/main" xmlns:r="http://schemas.openxmlformats.org/officeDocument/2006/relationships">
+  <p:cSld>
+    <p:spTree>
+      <p:nvGrpSpPr>
+        <p:cNvPr id="1" name=""/>
+        <p:cNvGrpSpPr/>
+        <p:nvPr/>
+      </p:nvGrpSpPr>
+      <p:grpSpPr>
+        <a:xfrm>
+          <a:off x="0" y="0"/>
+          <a:ext cx="0" cy="0"/>
+          <a:chOff x="0" y="0"/>
+          <a:chExt cx="0" cy="0"/>
+        </a:xfrm>
+      </p:grpSpPr>
+      <p:sp>
+        <p:nvSpPr>
+          <p:cNvPr id="2" name="Slide Image Placeholder 1"/>
+          <p:cNvSpPr>
+            <a:spLocks noGrp="1"/>
+          </p:cNvSpPr>
+          <p:nvPr>
+            <p:ph type="sldImg" idx="2"/>
+          </p:nvPr>
+        </p:nvSpPr>
+        <p:spPr/>
+      </p:sp>
+      <p:sp>
+        <p:nvSpPr>
+          <p:cNvPr id="3" name="Notes Placeholder 2"/>
+          <p:cNvSpPr>
+            <a:spLocks noGrp="1"/>
+          </p:cNvSpPr>
+          <p:nvPr>
+            <p:ph type="body" idx="3" sz="quarter"/>
+          </p:nvPr>
+        </p:nvSpPr>
+        <p:spPr/>
+        <p:txBody>
+          <a:bodyPr/>
+          <a:lstStyle/>
+          <a:p>
+            <a:r>
+              <a:t>Eight lifecycle events give you precise control over where hooks fire. PreToolUse is the most commonly used — fires before every tool call and lets you block dangerous operations. PostToolUse is great for enforcement after edits — run your linter, check test pass, auto-format. SessionStart is where you inject dynamic context that changes day-to-day. A common team pattern: PreToolUse to block force push and drop database commands, PostToolUse to auto-format and run static analysis after every file edit.</a:t>
+            </a:r>
+          </a:p>
+        </p:txBody>
+      </p:sp>
+      <p:sp>
+        <p:nvSpPr>
+          <p:cNvPr id="4" name="Slide Number Placeholder 3"/>
+          <p:cNvSpPr>
+            <a:spLocks noGrp="1"/>
+          </p:cNvSpPr>
+          <p:nvPr>
+            <p:ph type="sldNum" idx="5" sz="quarter"/>
+          </p:nvPr>
+        </p:nvSpPr>
+        <p:spPr/>
+      </p:sp>
+    </p:spTree>
+  </p:cSld>
+  <p:clrMapOvr>
+    <a:masterClrMapping/>
+  </p:clrMapOvr>
+</p:notes>
+</file>
+
+<file path=ppt/notesSlides/notesSlide33.xml><?xml version="1.0" encoding="utf-8"?>
+<p:notes xmlns:a="http://schemas.openxmlformats.org/drawingml/2006/main" xmlns:p="http://schemas.openxmlformats.org/presentationml/2006/main" xmlns:r="http://schemas.openxmlformats.org/officeDocument/2006/relationships">
+  <p:cSld>
+    <p:spTree>
+      <p:nvGrpSpPr>
+        <p:cNvPr id="1" name=""/>
+        <p:cNvGrpSpPr/>
+        <p:nvPr/>
+      </p:nvGrpSpPr>
+      <p:grpSpPr>
+        <a:xfrm>
+          <a:off x="0" y="0"/>
+          <a:ext cx="0" cy="0"/>
+          <a:chOff x="0" y="0"/>
+          <a:chExt cx="0" cy="0"/>
+        </a:xfrm>
+      </p:grpSpPr>
+      <p:sp>
+        <p:nvSpPr>
+          <p:cNvPr id="2" name="Slide Image Placeholder 1"/>
+          <p:cNvSpPr>
+            <a:spLocks noGrp="1"/>
+          </p:cNvSpPr>
+          <p:nvPr>
+            <p:ph type="sldImg" idx="2"/>
+          </p:nvPr>
+        </p:nvSpPr>
+        <p:spPr/>
+      </p:sp>
+      <p:sp>
+        <p:nvSpPr>
+          <p:cNvPr id="3" name="Notes Placeholder 2"/>
+          <p:cNvSpPr>
+            <a:spLocks noGrp="1"/>
+          </p:cNvSpPr>
+          <p:nvPr>
+            <p:ph type="body" idx="3" sz="quarter"/>
+          </p:nvPr>
+        </p:nvSpPr>
+        <p:spPr/>
+        <p:txBody>
+          <a:bodyPr/>
+          <a:lstStyle/>
+          <a:p>
+            <a:r>
+              <a:t>Now let's look at what actually happened when we built the PoC. Real projects hit real obstacles. These six cases are instructive because similar issues will come up for you on .NET 10 projects — some are SDK-level changes, others are subtle interface-matching problems that the agent had to diagnose and fix itself.</a:t>
+            </a:r>
+          </a:p>
+        </p:txBody>
+      </p:sp>
+      <p:sp>
+        <p:nvSpPr>
+          <p:cNvPr id="4" name="Slide Number Placeholder 3"/>
+          <p:cNvSpPr>
+            <a:spLocks noGrp="1"/>
+          </p:cNvSpPr>
+          <p:nvPr>
+            <p:ph type="sldNum" idx="5" sz="quarter"/>
+          </p:nvPr>
+        </p:nvSpPr>
+        <p:spPr/>
+      </p:sp>
+    </p:spTree>
+  </p:cSld>
+  <p:clrMapOvr>
+    <a:masterClrMapping/>
+  </p:clrMapOvr>
+</p:notes>
+</file>
+
+<file path=ppt/notesSlides/notesSlide34.xml><?xml version="1.0" encoding="utf-8"?>
+<p:notes xmlns:a="http://schemas.openxmlformats.org/drawingml/2006/main" xmlns:p="http://schemas.openxmlformats.org/presentationml/2006/main" xmlns:r="http://schemas.openxmlformats.org/officeDocument/2006/relationships">
+  <p:cSld>
+    <p:spTree>
+      <p:nvGrpSpPr>
+        <p:cNvPr id="1" name=""/>
+        <p:cNvGrpSpPr/>
+        <p:nvPr/>
+      </p:nvGrpSpPr>
+      <p:grpSpPr>
+        <a:xfrm>
+          <a:off x="0" y="0"/>
+          <a:ext cx="0" cy="0"/>
+          <a:chOff x="0" y="0"/>
+          <a:chExt cx="0" cy="0"/>
+        </a:xfrm>
+      </p:grpSpPr>
+      <p:sp>
+        <p:nvSpPr>
+          <p:cNvPr id="2" name="Slide Image Placeholder 1"/>
+          <p:cNvSpPr>
+            <a:spLocks noGrp="1"/>
+          </p:cNvSpPr>
+          <p:nvPr>
+            <p:ph type="sldImg" idx="2"/>
+          </p:nvPr>
+        </p:nvSpPr>
+        <p:spPr/>
+      </p:sp>
+      <p:sp>
+        <p:nvSpPr>
+          <p:cNvPr id="3" name="Notes Placeholder 2"/>
+          <p:cNvSpPr>
+            <a:spLocks noGrp="1"/>
+          </p:cNvSpPr>
+          <p:nvPr>
+            <p:ph type="body" idx="3" sz="quarter"/>
+          </p:nvPr>
+        </p:nvSpPr>
+        <p:spPr/>
+        <p:txBody>
+          <a:bodyPr/>
+          <a:lstStyle/>
+          <a:p>
+            <a:r>
+              <a:t>Six obstacles, all resolved. Two that will save you the most time on .NET 10 projects: first, dotnet new sln now creates a .slnx file, not .sln — if your agent keeps failing on solution file commands, check this. Second, the Moq StringSetAsync mismatch was subtle: the production code was calling an overload that Moq couldn't match implicitly. The fix was making the production call explicit about which overload it used, then updating the test setup to match exactly. The agent diagnosed this itself — identified the overload mismatch and fixed both files in one pass.</a:t>
+            </a:r>
+          </a:p>
+        </p:txBody>
+      </p:sp>
+      <p:sp>
+        <p:nvSpPr>
+          <p:cNvPr id="4" name="Slide Number Placeholder 3"/>
+          <p:cNvSpPr>
+            <a:spLocks noGrp="1"/>
+          </p:cNvSpPr>
+          <p:nvPr>
+            <p:ph type="sldNum" idx="5" sz="quarter"/>
+          </p:nvPr>
+        </p:nvSpPr>
+        <p:spPr/>
+      </p:sp>
+    </p:spTree>
+  </p:cSld>
+  <p:clrMapOvr>
+    <a:masterClrMapping/>
+  </p:clrMapOvr>
+</p:notes>
+</file>
+
+<file path=ppt/notesSlides/notesSlide35.xml><?xml version="1.0" encoding="utf-8"?>
+<p:notes xmlns:a="http://schemas.openxmlformats.org/drawingml/2006/main" xmlns:p="http://schemas.openxmlformats.org/presentationml/2006/main" xmlns:r="http://schemas.openxmlformats.org/officeDocument/2006/relationships">
+  <p:cSld>
+    <p:spTree>
+      <p:nvGrpSpPr>
+        <p:cNvPr id="1" name=""/>
+        <p:cNvGrpSpPr/>
+        <p:nvPr/>
+      </p:nvGrpSpPr>
+      <p:grpSpPr>
+        <a:xfrm>
+          <a:off x="0" y="0"/>
+          <a:ext cx="0" cy="0"/>
+          <a:chOff x="0" y="0"/>
+          <a:chExt cx="0" cy="0"/>
+        </a:xfrm>
+      </p:grpSpPr>
+      <p:sp>
+        <p:nvSpPr>
+          <p:cNvPr id="2" name="Slide Image Placeholder 1"/>
+          <p:cNvSpPr>
+            <a:spLocks noGrp="1"/>
+          </p:cNvSpPr>
+          <p:nvPr>
+            <p:ph type="sldImg" idx="2"/>
+          </p:nvPr>
+        </p:nvSpPr>
+        <p:spPr/>
+      </p:sp>
+      <p:sp>
+        <p:nvSpPr>
+          <p:cNvPr id="3" name="Notes Placeholder 2"/>
+          <p:cNvSpPr>
+            <a:spLocks noGrp="1"/>
+          </p:cNvSpPr>
+          <p:nvPr>
+            <p:ph type="body" idx="3" sz="quarter"/>
+          </p:nvPr>
+        </p:nvSpPr>
+        <p:spPr/>
+        <p:txBody>
+          <a:bodyPr/>
+          <a:lstStyle/>
+          <a:p>
+            <a:r>
+              <a:t>Let's close with the practices that separate teams getting consistent value from Copilot from teams who are frustrated by it. Most of the frustration comes from a small set of avoidable patterns.</a:t>
+            </a:r>
+          </a:p>
+        </p:txBody>
+      </p:sp>
+      <p:sp>
+        <p:nvSpPr>
+          <p:cNvPr id="4" name="Slide Number Placeholder 3"/>
+          <p:cNvSpPr>
+            <a:spLocks noGrp="1"/>
+          </p:cNvSpPr>
+          <p:nvPr>
+            <p:ph type="sldNum" idx="5" sz="quarter"/>
+          </p:nvPr>
+        </p:nvSpPr>
+        <p:spPr/>
+      </p:sp>
+    </p:spTree>
+  </p:cSld>
+  <p:clrMapOvr>
+    <a:masterClrMapping/>
+  </p:clrMapOvr>
+</p:notes>
+</file>
+
+<file path=ppt/notesSlides/notesSlide36.xml><?xml version="1.0" encoding="utf-8"?>
+<p:notes xmlns:a="http://schemas.openxmlformats.org/drawingml/2006/main" xmlns:p="http://schemas.openxmlformats.org/presentationml/2006/main" xmlns:r="http://schemas.openxmlformats.org/officeDocument/2006/relationships">
+  <p:cSld>
+    <p:spTree>
+      <p:nvGrpSpPr>
+        <p:cNvPr id="1" name=""/>
+        <p:cNvGrpSpPr/>
+        <p:nvPr/>
+      </p:nvGrpSpPr>
+      <p:grpSpPr>
+        <a:xfrm>
+          <a:off x="0" y="0"/>
+          <a:ext cx="0" cy="0"/>
+          <a:chOff x="0" y="0"/>
+          <a:chExt cx="0" cy="0"/>
+        </a:xfrm>
+      </p:grpSpPr>
+      <p:sp>
+        <p:nvSpPr>
+          <p:cNvPr id="2" name="Slide Image Placeholder 1"/>
+          <p:cNvSpPr>
+            <a:spLocks noGrp="1"/>
+          </p:cNvSpPr>
+          <p:nvPr>
+            <p:ph type="sldImg" idx="2"/>
+          </p:nvPr>
+        </p:nvSpPr>
+        <p:spPr/>
+      </p:sp>
+      <p:sp>
+        <p:nvSpPr>
+          <p:cNvPr id="3" name="Notes Placeholder 2"/>
+          <p:cNvSpPr>
+            <a:spLocks noGrp="1"/>
+          </p:cNvSpPr>
+          <p:nvPr>
+            <p:ph type="body" idx="3" sz="quarter"/>
+          </p:nvPr>
+        </p:nvSpPr>
+        <p:spPr/>
+        <p:txBody>
+          <a:bodyPr/>
+          <a:lstStyle/>
+          <a:p>
+            <a:r>
+              <a:t>Two highest-leverage practices: run /init on every new repo before writing any code — it gives the agent accurate build commands and architecture context from day one. And answer /plan questionnaires completely — the plan quality is a direct function of your answer quality. On the common mistakes side: the YAML frontmatter trap is worth calling out specifically — values containing colons must be quoted, and a missing quote silently breaks your customization file with no error or warning.</a:t>
+            </a:r>
+          </a:p>
+        </p:txBody>
+      </p:sp>
+      <p:sp>
+        <p:nvSpPr>
+          <p:cNvPr id="4" name="Slide Number Placeholder 3"/>
+          <p:cNvSpPr>
+            <a:spLocks noGrp="1"/>
+          </p:cNvSpPr>
+          <p:nvPr>
+            <p:ph type="sldNum" idx="5" sz="quarter"/>
+          </p:nvPr>
+        </p:nvSpPr>
+        <p:spPr/>
+      </p:sp>
+    </p:spTree>
+  </p:cSld>
+  <p:clrMapOvr>
+    <a:masterClrMapping/>
+  </p:clrMapOvr>
+</p:notes>
+</file>
+
+<file path=ppt/notesSlides/notesSlide37.xml><?xml version="1.0" encoding="utf-8"?>
+<p:notes xmlns:a="http://schemas.openxmlformats.org/drawingml/2006/main" xmlns:p="http://schemas.openxmlformats.org/presentationml/2006/main" xmlns:r="http://schemas.openxmlformats.org/officeDocument/2006/relationships">
+  <p:cSld>
+    <p:spTree>
+      <p:nvGrpSpPr>
+        <p:cNvPr id="1" name=""/>
+        <p:cNvGrpSpPr/>
+        <p:nvPr/>
+      </p:nvGrpSpPr>
+      <p:grpSpPr>
+        <a:xfrm>
+          <a:off x="0" y="0"/>
+          <a:ext cx="0" cy="0"/>
+          <a:chOff x="0" y="0"/>
+          <a:chExt cx="0" cy="0"/>
+        </a:xfrm>
+      </p:grpSpPr>
+      <p:sp>
+        <p:nvSpPr>
+          <p:cNvPr id="2" name="Slide Image Placeholder 1"/>
+          <p:cNvSpPr>
+            <a:spLocks noGrp="1"/>
+          </p:cNvSpPr>
+          <p:nvPr>
+            <p:ph type="sldImg" idx="2"/>
+          </p:nvPr>
+        </p:nvSpPr>
+        <p:spPr/>
+      </p:sp>
+      <p:sp>
+        <p:nvSpPr>
+          <p:cNvPr id="3" name="Notes Placeholder 2"/>
+          <p:cNvSpPr>
+            <a:spLocks noGrp="1"/>
+          </p:cNvSpPr>
+          <p:nvPr>
+            <p:ph type="body" idx="3" sz="quarter"/>
+          </p:nvPr>
+        </p:nvSpPr>
+        <p:spPr/>
+        <p:txBody>
+          <a:bodyPr/>
+          <a:lstStyle/>
+          <a:p>
+            <a:r>
+              <a:t>Security deserves its own slide. Generated code is never automatically correct from a security standpoint — treat every generated file as a PR artifact that needs review. The checklist here is what I personally run through on any AI-generated auth code: algorithm pinned to RS256, both issuer and audience validated, cookies have all three flags, CORS locked to a specific origin. The good news: write these rules into an .instructions.md file and the agent enforces them on every piece of code it generates for the rest of the session.</a:t>
+            </a:r>
+          </a:p>
+        </p:txBody>
+      </p:sp>
+      <p:sp>
+        <p:nvSpPr>
+          <p:cNvPr id="4" name="Slide Number Placeholder 3"/>
+          <p:cNvSpPr>
+            <a:spLocks noGrp="1"/>
+          </p:cNvSpPr>
+          <p:nvPr>
+            <p:ph type="sldNum" idx="5" sz="quarter"/>
+          </p:nvPr>
+        </p:nvSpPr>
+        <p:spPr/>
+      </p:sp>
+    </p:spTree>
+  </p:cSld>
+  <p:clrMapOvr>
+    <a:masterClrMapping/>
+  </p:clrMapOvr>
+</p:notes>
+</file>
+
+<file path=ppt/notesSlides/notesSlide38.xml><?xml version="1.0" encoding="utf-8"?>
+<p:notes xmlns:a="http://schemas.openxmlformats.org/drawingml/2006/main" xmlns:p="http://schemas.openxmlformats.org/presentationml/2006/main" xmlns:r="http://schemas.openxmlformats.org/officeDocument/2006/relationships">
+  <p:cSld>
+    <p:spTree>
+      <p:nvGrpSpPr>
+        <p:cNvPr id="1" name=""/>
+        <p:cNvGrpSpPr/>
+        <p:nvPr/>
+      </p:nvGrpSpPr>
+      <p:grpSpPr>
+        <a:xfrm>
+          <a:off x="0" y="0"/>
+          <a:ext cx="0" cy="0"/>
+          <a:chOff x="0" y="0"/>
+          <a:chExt cx="0" cy="0"/>
+        </a:xfrm>
+      </p:grpSpPr>
+      <p:sp>
+        <p:nvSpPr>
+          <p:cNvPr id="2" name="Slide Image Placeholder 1"/>
+          <p:cNvSpPr>
+            <a:spLocks noGrp="1"/>
+          </p:cNvSpPr>
+          <p:nvPr>
+            <p:ph type="sldImg" idx="2"/>
+          </p:nvPr>
+        </p:nvSpPr>
+        <p:spPr/>
+      </p:sp>
+      <p:sp>
+        <p:nvSpPr>
+          <p:cNvPr id="3" name="Notes Placeholder 2"/>
+          <p:cNvSpPr>
+            <a:spLocks noGrp="1"/>
+          </p:cNvSpPr>
+          <p:nvPr>
+            <p:ph type="body" idx="3" sz="quarter"/>
+          </p:nvPr>
+        </p:nvSpPr>
+        <p:spPr/>
+        <p:txBody>
+          <a:bodyPr/>
+          <a:lstStyle/>
+          <a:p>
+            <a:r>
+              <a:t>These six steps are your starting checklist — you can do the first three right now. /plan with your current backlog item, /init on the repo you're working in, /create-instructions to capture the patterns from this conversation. That's the fastest path from zero to a team-wide Copilot setup that produces consistent results. I'll drop the repo link in the chat — all the customization files we discussed are in there. Questions?</a:t>
+            </a:r>
+          </a:p>
+        </p:txBody>
+      </p:sp>
+      <p:sp>
+        <p:nvSpPr>
+          <p:cNvPr id="4" name="Slide Number Placeholder 3"/>
+          <p:cNvSpPr>
+            <a:spLocks noGrp="1"/>
+          </p:cNvSpPr>
+          <p:nvPr>
+            <p:ph type="sldNum" idx="5" sz="quarter"/>
+          </p:nvPr>
+        </p:nvSpPr>
+        <p:spPr/>
+      </p:sp>
+    </p:spTree>
+  </p:cSld>
+  <p:clrMapOvr>
+    <a:masterClrMapping/>
+  </p:clrMapOvr>
+</p:notes>
+</file>
+
+<file path=ppt/notesSlides/notesSlide4.xml><?xml version="1.0" encoding="utf-8"?>
+<p:notes xmlns:a="http://schemas.openxmlformats.org/drawingml/2006/main" xmlns:p="http://schemas.openxmlformats.org/presentationml/2006/main" xmlns:r="http://schemas.openxmlformats.org/officeDocument/2006/relationships">
+  <p:cSld>
+    <p:spTree>
+      <p:nvGrpSpPr>
+        <p:cNvPr id="1" name=""/>
+        <p:cNvGrpSpPr/>
+        <p:nvPr/>
+      </p:nvGrpSpPr>
+      <p:grpSpPr>
+        <a:xfrm>
+          <a:off x="0" y="0"/>
+          <a:ext cx="0" cy="0"/>
+          <a:chOff x="0" y="0"/>
+          <a:chExt cx="0" cy="0"/>
+        </a:xfrm>
+      </p:grpSpPr>
+      <p:sp>
+        <p:nvSpPr>
+          <p:cNvPr id="2" name="Slide Image Placeholder 1"/>
+          <p:cNvSpPr>
+            <a:spLocks noGrp="1"/>
+          </p:cNvSpPr>
+          <p:nvPr>
+            <p:ph type="sldImg" idx="2"/>
+          </p:nvPr>
+        </p:nvSpPr>
+        <p:spPr/>
+      </p:sp>
+      <p:sp>
+        <p:nvSpPr>
+          <p:cNvPr id="3" name="Notes Placeholder 2"/>
+          <p:cNvSpPr>
+            <a:spLocks noGrp="1"/>
+          </p:cNvSpPr>
+          <p:nvPr>
+            <p:ph type="body" idx="3" sz="quarter"/>
+          </p:nvPr>
+        </p:nvSpPr>
+        <p:spPr/>
+        <p:txBody>
+          <a:bodyPr/>
+          <a:lstStyle/>
+          <a:p>
+            <a:r>
+              <a:t>The key distinction here is the two surfaces. Inline completions are the next-token suggestions while typing — useful, but just autocomplete. Copilot Chat in agent mode is something else entirely: a full autonomous agent that can read your entire codebase, run shell commands, edit multiple files, and run your tests. The model powering it right now is Claude Sonnet 4.6. And critically — everything the agent does is shaped by your customization files, which is most of what this talk is about.</a:t>
+            </a:r>
+          </a:p>
+        </p:txBody>
+      </p:sp>
+      <p:sp>
+        <p:nvSpPr>
+          <p:cNvPr id="4" name="Slide Number Placeholder 3"/>
+          <p:cNvSpPr>
+            <a:spLocks noGrp="1"/>
+          </p:cNvSpPr>
+          <p:nvPr>
+            <p:ph type="sldNum" idx="5" sz="quarter"/>
+          </p:nvPr>
+        </p:nvSpPr>
+        <p:spPr/>
+      </p:sp>
+    </p:spTree>
+  </p:cSld>
+  <p:clrMapOvr>
+    <a:masterClrMapping/>
+  </p:clrMapOvr>
+</p:notes>
+</file>
+
+<file path=ppt/notesSlides/notesSlide5.xml><?xml version="1.0" encoding="utf-8"?>
+<p:notes xmlns:a="http://schemas.openxmlformats.org/drawingml/2006/main" xmlns:p="http://schemas.openxmlformats.org/presentationml/2006/main" xmlns:r="http://schemas.openxmlformats.org/officeDocument/2006/relationships">
+  <p:cSld>
+    <p:spTree>
+      <p:nvGrpSpPr>
+        <p:cNvPr id="1" name=""/>
+        <p:cNvGrpSpPr/>
+        <p:nvPr/>
+      </p:nvGrpSpPr>
+      <p:grpSpPr>
+        <a:xfrm>
+          <a:off x="0" y="0"/>
+          <a:ext cx="0" cy="0"/>
+          <a:chOff x="0" y="0"/>
+          <a:chExt cx="0" cy="0"/>
+        </a:xfrm>
+      </p:grpSpPr>
+      <p:sp>
+        <p:nvSpPr>
+          <p:cNvPr id="2" name="Slide Image Placeholder 1"/>
+          <p:cNvSpPr>
+            <a:spLocks noGrp="1"/>
+          </p:cNvSpPr>
+          <p:nvPr>
+            <p:ph type="sldImg" idx="2"/>
+          </p:nvPr>
+        </p:nvSpPr>
+        <p:spPr/>
+      </p:sp>
+      <p:sp>
+        <p:nvSpPr>
+          <p:cNvPr id="3" name="Notes Placeholder 2"/>
+          <p:cNvSpPr>
+            <a:spLocks noGrp="1"/>
+          </p:cNvSpPr>
+          <p:nvPr>
+            <p:ph type="body" idx="3" sz="quarter"/>
+          </p:nvPr>
+        </p:nvSpPr>
+        <p:spPr/>
+        <p:txBody>
+          <a:bodyPr/>
+          <a:lstStyle/>
+          <a:p>
+            <a:r>
+              <a:t>The slash commands are the first place most developers stumble on power they didn't know existed. Let's look at what each one actually does.</a:t>
+            </a:r>
+          </a:p>
+        </p:txBody>
+      </p:sp>
+      <p:sp>
+        <p:nvSpPr>
+          <p:cNvPr id="4" name="Slide Number Placeholder 3"/>
+          <p:cNvSpPr>
+            <a:spLocks noGrp="1"/>
+          </p:cNvSpPr>
+          <p:nvPr>
+            <p:ph type="sldNum" idx="5" sz="quarter"/>
+          </p:nvPr>
+        </p:nvSpPr>
+        <p:spPr/>
+      </p:sp>
+    </p:spTree>
+  </p:cSld>
+  <p:clrMapOvr>
+    <a:masterClrMapping/>
+  </p:clrMapOvr>
+</p:notes>
+</file>
+
+<file path=ppt/notesSlides/notesSlide6.xml><?xml version="1.0" encoding="utf-8"?>
+<p:notes xmlns:a="http://schemas.openxmlformats.org/drawingml/2006/main" xmlns:p="http://schemas.openxmlformats.org/presentationml/2006/main" xmlns:r="http://schemas.openxmlformats.org/officeDocument/2006/relationships">
+  <p:cSld>
+    <p:spTree>
+      <p:nvGrpSpPr>
+        <p:cNvPr id="1" name=""/>
+        <p:cNvGrpSpPr/>
+        <p:nvPr/>
+      </p:nvGrpSpPr>
+      <p:grpSpPr>
+        <a:xfrm>
+          <a:off x="0" y="0"/>
+          <a:ext cx="0" cy="0"/>
+          <a:chOff x="0" y="0"/>
+          <a:chExt cx="0" cy="0"/>
+        </a:xfrm>
+      </p:grpSpPr>
+      <p:sp>
+        <p:nvSpPr>
+          <p:cNvPr id="2" name="Slide Image Placeholder 1"/>
+          <p:cNvSpPr>
+            <a:spLocks noGrp="1"/>
+          </p:cNvSpPr>
+          <p:nvPr>
+            <p:ph type="sldImg" idx="2"/>
+          </p:nvPr>
+        </p:nvSpPr>
+        <p:spPr/>
+      </p:sp>
+      <p:sp>
+        <p:nvSpPr>
+          <p:cNvPr id="3" name="Notes Placeholder 2"/>
+          <p:cNvSpPr>
+            <a:spLocks noGrp="1"/>
+          </p:cNvSpPr>
+          <p:nvPr>
+            <p:ph type="body" idx="3" sz="quarter"/>
+          </p:nvPr>
+        </p:nvSpPr>
+        <p:spPr/>
+        <p:txBody>
+          <a:bodyPr/>
+          <a:lstStyle/>
+          <a:p>
+            <a:r>
+              <a:t>These are the slash commands baked into Copilot — most developers know maybe one of these. The one I want to highlight is /plan — it's more sophisticated than it looks. But the others are worth knowing: /init bootstraps a new repo with baseline instructions, and the /create-* family turns good patterns from a conversation into reusable team assets. Think of this table as your onboarding checklist for any new repo you start working with Copilot.</a:t>
+            </a:r>
+          </a:p>
+        </p:txBody>
+      </p:sp>
+      <p:sp>
+        <p:nvSpPr>
+          <p:cNvPr id="4" name="Slide Number Placeholder 3"/>
+          <p:cNvSpPr>
+            <a:spLocks noGrp="1"/>
+          </p:cNvSpPr>
+          <p:nvPr>
+            <p:ph type="sldNum" idx="5" sz="quarter"/>
+          </p:nvPr>
+        </p:nvSpPr>
+        <p:spPr/>
+      </p:sp>
+    </p:spTree>
+  </p:cSld>
+  <p:clrMapOvr>
+    <a:masterClrMapping/>
+  </p:clrMapOvr>
+</p:notes>
+</file>
+
+<file path=ppt/notesSlides/notesSlide7.xml><?xml version="1.0" encoding="utf-8"?>
+<p:notes xmlns:a="http://schemas.openxmlformats.org/drawingml/2006/main" xmlns:p="http://schemas.openxmlformats.org/presentationml/2006/main" xmlns:r="http://schemas.openxmlformats.org/officeDocument/2006/relationships">
+  <p:cSld>
+    <p:spTree>
+      <p:nvGrpSpPr>
+        <p:cNvPr id="1" name=""/>
+        <p:cNvGrpSpPr/>
+        <p:nvPr/>
+      </p:nvGrpSpPr>
+      <p:grpSpPr>
+        <a:xfrm>
+          <a:off x="0" y="0"/>
+          <a:ext cx="0" cy="0"/>
+          <a:chOff x="0" y="0"/>
+          <a:chExt cx="0" cy="0"/>
+        </a:xfrm>
+      </p:grpSpPr>
+      <p:sp>
+        <p:nvSpPr>
+          <p:cNvPr id="2" name="Slide Image Placeholder 1"/>
+          <p:cNvSpPr>
+            <a:spLocks noGrp="1"/>
+          </p:cNvSpPr>
+          <p:nvPr>
+            <p:ph type="sldImg" idx="2"/>
+          </p:nvPr>
+        </p:nvSpPr>
+        <p:spPr/>
+      </p:sp>
+      <p:sp>
+        <p:nvSpPr>
+          <p:cNvPr id="3" name="Notes Placeholder 2"/>
+          <p:cNvSpPr>
+            <a:spLocks noGrp="1"/>
+          </p:cNvSpPr>
+          <p:nvPr>
+            <p:ph type="body" idx="3" sz="quarter"/>
+          </p:nvPr>
+        </p:nvSpPr>
+        <p:spPr/>
+        <p:txBody>
+          <a:bodyPr/>
+          <a:lstStyle/>
+          <a:p>
+            <a:r>
+              <a:t>Let's pull back the curtain on /plan. Most people type it, get a plan, and move on without understanding what actually happened. Understanding the machinery helps you give better inputs — and better inputs means better plans.</a:t>
+            </a:r>
+          </a:p>
+        </p:txBody>
+      </p:sp>
+      <p:sp>
+        <p:nvSpPr>
+          <p:cNvPr id="4" name="Slide Number Placeholder 3"/>
+          <p:cNvSpPr>
+            <a:spLocks noGrp="1"/>
+          </p:cNvSpPr>
+          <p:nvPr>
+            <p:ph type="sldNum" idx="5" sz="quarter"/>
+          </p:nvPr>
+        </p:nvSpPr>
+        <p:spPr/>
+      </p:sp>
+    </p:spTree>
+  </p:cSld>
+  <p:clrMapOvr>
+    <a:masterClrMapping/>
+  </p:clrMapOvr>
+</p:notes>
+</file>
+
+<file path=ppt/notesSlides/notesSlide8.xml><?xml version="1.0" encoding="utf-8"?>
+<p:notes xmlns:a="http://schemas.openxmlformats.org/drawingml/2006/main" xmlns:p="http://schemas.openxmlformats.org/presentationml/2006/main" xmlns:r="http://schemas.openxmlformats.org/officeDocument/2006/relationships">
+  <p:cSld>
+    <p:spTree>
+      <p:nvGrpSpPr>
+        <p:cNvPr id="1" name=""/>
+        <p:cNvGrpSpPr/>
+        <p:nvPr/>
+      </p:nvGrpSpPr>
+      <p:grpSpPr>
+        <a:xfrm>
+          <a:off x="0" y="0"/>
+          <a:ext cx="0" cy="0"/>
+          <a:chOff x="0" y="0"/>
+          <a:chExt cx="0" cy="0"/>
+        </a:xfrm>
+      </p:grpSpPr>
+      <p:sp>
+        <p:nvSpPr>
+          <p:cNvPr id="2" name="Slide Image Placeholder 1"/>
+          <p:cNvSpPr>
+            <a:spLocks noGrp="1"/>
+          </p:cNvSpPr>
+          <p:nvPr>
+            <p:ph type="sldImg" idx="2"/>
+          </p:nvPr>
+        </p:nvSpPr>
+        <p:spPr/>
+      </p:sp>
+      <p:sp>
+        <p:nvSpPr>
+          <p:cNvPr id="3" name="Notes Placeholder 2"/>
+          <p:cNvSpPr>
+            <a:spLocks noGrp="1"/>
+          </p:cNvSpPr>
+          <p:nvPr>
+            <p:ph type="body" idx="3" sz="quarter"/>
+          </p:nvPr>
+        </p:nvSpPr>
+        <p:spPr/>
+        <p:txBody>
+          <a:bodyPr/>
+          <a:lstStyle/>
+          <a:p>
+            <a:r>
+              <a:t>Here's the actual source file for /plan — the whole thing is 7 lines. This is not where the intelligence lives; it's just a routing declaration. It says: when someone types /plan, run the built-in Plan agent, not the default agent. The description field shows in the command picker. The magic is inside the Plan agent itself, not in this file. Understanding this structure matters because your own .prompt.md files use the exact same format.</a:t>
+            </a:r>
+          </a:p>
+        </p:txBody>
+      </p:sp>
+      <p:sp>
+        <p:nvSpPr>
+          <p:cNvPr id="4" name="Slide Number Placeholder 3"/>
+          <p:cNvSpPr>
+            <a:spLocks noGrp="1"/>
+          </p:cNvSpPr>
+          <p:nvPr>
+            <p:ph type="sldNum" idx="5" sz="quarter"/>
+          </p:nvPr>
+        </p:nvSpPr>
+        <p:spPr/>
+      </p:sp>
+    </p:spTree>
+  </p:cSld>
+  <p:clrMapOvr>
+    <a:masterClrMapping/>
+  </p:clrMapOvr>
+</p:notes>
+</file>
+
+<file path=ppt/notesSlides/notesSlide9.xml><?xml version="1.0" encoding="utf-8"?>
+<p:notes xmlns:a="http://schemas.openxmlformats.org/drawingml/2006/main" xmlns:p="http://schemas.openxmlformats.org/presentationml/2006/main" xmlns:r="http://schemas.openxmlformats.org/officeDocument/2006/relationships">
+  <p:cSld>
+    <p:spTree>
+      <p:nvGrpSpPr>
+        <p:cNvPr id="1" name=""/>
+        <p:cNvGrpSpPr/>
+        <p:nvPr/>
+      </p:nvGrpSpPr>
+      <p:grpSpPr>
+        <a:xfrm>
+          <a:off x="0" y="0"/>
+          <a:ext cx="0" cy="0"/>
+          <a:chOff x="0" y="0"/>
+          <a:chExt cx="0" cy="0"/>
+        </a:xfrm>
+      </p:grpSpPr>
+      <p:sp>
+        <p:nvSpPr>
+          <p:cNvPr id="2" name="Slide Image Placeholder 1"/>
+          <p:cNvSpPr>
+            <a:spLocks noGrp="1"/>
+          </p:cNvSpPr>
+          <p:nvPr>
+            <p:ph type="sldImg" idx="2"/>
+          </p:nvPr>
+        </p:nvSpPr>
+        <p:spPr/>
+      </p:sp>
+      <p:sp>
+        <p:nvSpPr>
+          <p:cNvPr id="3" name="Notes Placeholder 2"/>
+          <p:cNvSpPr>
+            <a:spLocks noGrp="1"/>
+          </p:cNvSpPr>
+          <p:nvPr>
+            <p:ph type="body" idx="3" sz="quarter"/>
+          </p:nvPr>
+        </p:nvSpPr>
+        <p:spPr/>
+        <p:txBody>
+          <a:bodyPr/>
+          <a:lstStyle/>
+          <a:p>
+            <a:r>
+              <a:t>So what does the Plan agent actually do with your request? It starts by analyzing what you asked and figuring out what it doesn't know — the gaps. That's where the questionnaire comes from. It's not random questions; it's a targeted interview about the specific decisions it needs to make your plan concrete. Once you answer, it maps answers to technology choices, creates a dependency-ordered sequence of phases, and then — this is the part people miss — saves the whole plan to session memory so it persists throughout your entire implementation session.</a:t>
+            </a:r>
+          </a:p>
+        </p:txBody>
+      </p:sp>
+      <p:sp>
+        <p:nvSpPr>
+          <p:cNvPr id="4" name="Slide Number Placeholder 3"/>
+          <p:cNvSpPr>
+            <a:spLocks noGrp="1"/>
+          </p:cNvSpPr>
+          <p:nvPr>
+            <p:ph type="sldNum" idx="5" sz="quarter"/>
+          </p:nvPr>
+        </p:nvSpPr>
+        <p:spPr/>
+      </p:sp>
+    </p:spTree>
+  </p:cSld>
+  <p:clrMapOvr>
+    <a:masterClrMapping/>
+  </p:clrMapOvr>
+</p:notes>
 </file>
 
 <file path=ppt/slideLayouts/slideLayout1.xml><?xml version="1.0" encoding="utf-8"?>
@@ -22228,4 +25238,324 @@
   </a:objectDefaults>
   <a:extraClrSchemeLst/>
 </a:theme>
+</file>
+
+<file path=ppt/theme/theme2.xml><?xml version="1.0" encoding="utf-8"?>
+<a:theme xmlns:a="http://schemas.openxmlformats.org/drawingml/2006/main" name="Office Theme">
+  <a:themeElements>
+    <a:clrScheme name="Office">
+      <a:dk1>
+        <a:sysClr val="windowText" lastClr="000000"/>
+      </a:dk1>
+      <a:lt1>
+        <a:sysClr val="window" lastClr="FFFFFF"/>
+      </a:lt1>
+      <a:dk2>
+        <a:srgbClr val="1F497D"/>
+      </a:dk2>
+      <a:lt2>
+        <a:srgbClr val="EEECE1"/>
+      </a:lt2>
+      <a:accent1>
+        <a:srgbClr val="4F81BD"/>
+      </a:accent1>
+      <a:accent2>
+        <a:srgbClr val="C0504D"/>
+      </a:accent2>
+      <a:accent3>
+        <a:srgbClr val="9BBB59"/>
+      </a:accent3>
+      <a:accent4>
+        <a:srgbClr val="8064A2"/>
+      </a:accent4>
+      <a:accent5>
+        <a:srgbClr val="4BACC6"/>
+      </a:accent5>
+      <a:accent6>
+        <a:srgbClr val="F79646"/>
+      </a:accent6>
+      <a:hlink>
+        <a:srgbClr val="0000FF"/>
+      </a:hlink>
+      <a:folHlink>
+        <a:srgbClr val="800080"/>
+      </a:folHlink>
+    </a:clrScheme>
+    <a:fontScheme name="Office">
+      <a:majorFont>
+        <a:latin typeface="Calibri"/>
+        <a:ea typeface=""/>
+        <a:cs typeface=""/>
+        <a:font script="Jpan" typeface="ＭＳ Ｐゴシック"/>
+        <a:font script="Hang" typeface="맑은 고딕"/>
+        <a:font script="Hans" typeface="宋体"/>
+        <a:font script="Hant" typeface="新細明體"/>
+        <a:font script="Arab" typeface="Times New Roman"/>
+        <a:font script="Hebr" typeface="Times New Roman"/>
+        <a:font script="Thai" typeface="Angsana New"/>
+        <a:font script="Ethi" typeface="Nyala"/>
+        <a:font script="Beng" typeface="Vrinda"/>
+        <a:font script="Gujr" typeface="Shruti"/>
+        <a:font script="Khmr" typeface="MoolBoran"/>
+        <a:font script="Knda" typeface="Tunga"/>
+        <a:font script="Guru" typeface="Raavi"/>
+        <a:font script="Cans" typeface="Euphemia"/>
+        <a:font script="Cher" typeface="Plantagenet Cherokee"/>
+        <a:font script="Yiii" typeface="Microsoft Yi Baiti"/>
+        <a:font script="Tibt" typeface="Microsoft Himalaya"/>
+        <a:font script="Thaa" typeface="MV Boli"/>
+        <a:font script="Deva" typeface="Mangal"/>
+        <a:font script="Telu" typeface="Gautami"/>
+        <a:font script="Taml" typeface="Latha"/>
+        <a:font script="Syrc" typeface="Estrangelo Edessa"/>
+        <a:font script="Orya" typeface="Kalinga"/>
+        <a:font script="Mlym" typeface="Kartika"/>
+        <a:font script="Laoo" typeface="DokChampa"/>
+        <a:font script="Sinh" typeface="Iskoola Pota"/>
+        <a:font script="Mong" typeface="Mongolian Baiti"/>
+        <a:font script="Viet" typeface="Times New Roman"/>
+        <a:font script="Uigh" typeface="Microsoft Uighur"/>
+        <a:font script="Geor" typeface="Sylfaen"/>
+      </a:majorFont>
+      <a:minorFont>
+        <a:latin typeface="Calibri"/>
+        <a:ea typeface=""/>
+        <a:cs typeface=""/>
+        <a:font script="Jpan" typeface="ＭＳ Ｐゴシック"/>
+        <a:font script="Hang" typeface="맑은 고딕"/>
+        <a:font script="Hans" typeface="宋体"/>
+        <a:font script="Hant" typeface="新細明體"/>
+        <a:font script="Arab" typeface="Arial"/>
+        <a:font script="Hebr" typeface="Arial"/>
+        <a:font script="Thai" typeface="Cordia New"/>
+        <a:font script="Ethi" typeface="Nyala"/>
+        <a:font script="Beng" typeface="Vrinda"/>
+        <a:font script="Gujr" typeface="Shruti"/>
+        <a:font script="Khmr" typeface="DaunPenh"/>
+        <a:font script="Knda" typeface="Tunga"/>
+        <a:font script="Guru" typeface="Raavi"/>
+        <a:font script="Cans" typeface="Euphemia"/>
+        <a:font script="Cher" typeface="Plantagenet Cherokee"/>
+        <a:font script="Yiii" typeface="Microsoft Yi Baiti"/>
+        <a:font script="Tibt" typeface="Microsoft Himalaya"/>
+        <a:font script="Thaa" typeface="MV Boli"/>
+        <a:font script="Deva" typeface="Mangal"/>
+        <a:font script="Telu" typeface="Gautami"/>
+        <a:font script="Taml" typeface="Latha"/>
+        <a:font script="Syrc" typeface="Estrangelo Edessa"/>
+        <a:font script="Orya" typeface="Kalinga"/>
+        <a:font script="Mlym" typeface="Kartika"/>
+        <a:font script="Laoo" typeface="DokChampa"/>
+        <a:font script="Sinh" typeface="Iskoola Pota"/>
+        <a:font script="Mong" typeface="Mongolian Baiti"/>
+        <a:font script="Viet" typeface="Arial"/>
+        <a:font script="Uigh" typeface="Microsoft Uighur"/>
+        <a:font script="Geor" typeface="Sylfaen"/>
+      </a:minorFont>
+    </a:fontScheme>
+    <a:fmtScheme name="Office">
+      <a:fillStyleLst>
+        <a:solidFill>
+          <a:schemeClr val="phClr"/>
+        </a:solidFill>
+        <a:gradFill rotWithShape="1">
+          <a:gsLst>
+            <a:gs pos="0">
+              <a:schemeClr val="phClr">
+                <a:tint val="50000"/>
+                <a:satMod val="300000"/>
+              </a:schemeClr>
+            </a:gs>
+            <a:gs pos="35000">
+              <a:schemeClr val="phClr">
+                <a:tint val="37000"/>
+                <a:satMod val="300000"/>
+              </a:schemeClr>
+            </a:gs>
+            <a:gs pos="100000">
+              <a:schemeClr val="phClr">
+                <a:tint val="15000"/>
+                <a:satMod val="350000"/>
+              </a:schemeClr>
+            </a:gs>
+          </a:gsLst>
+          <a:lin ang="16200000" scaled="1"/>
+        </a:gradFill>
+        <a:gradFill rotWithShape="1">
+          <a:gsLst>
+            <a:gs pos="0">
+              <a:schemeClr val="phClr">
+                <a:tint val="100000"/>
+                <a:shade val="100000"/>
+                <a:satMod val="130000"/>
+              </a:schemeClr>
+            </a:gs>
+            <a:gs pos="100000">
+              <a:schemeClr val="phClr">
+                <a:tint val="50000"/>
+                <a:shade val="100000"/>
+                <a:satMod val="350000"/>
+              </a:schemeClr>
+            </a:gs>
+          </a:gsLst>
+          <a:lin ang="16200000" scaled="0"/>
+        </a:gradFill>
+      </a:fillStyleLst>
+      <a:lnStyleLst>
+        <a:ln w="9525" cap="flat" cmpd="sng" algn="ctr">
+          <a:solidFill>
+            <a:schemeClr val="phClr">
+              <a:shade val="95000"/>
+              <a:satMod val="105000"/>
+            </a:schemeClr>
+          </a:solidFill>
+          <a:prstDash val="solid"/>
+        </a:ln>
+        <a:ln w="25400" cap="flat" cmpd="sng" algn="ctr">
+          <a:solidFill>
+            <a:schemeClr val="phClr"/>
+          </a:solidFill>
+          <a:prstDash val="solid"/>
+        </a:ln>
+        <a:ln w="38100" cap="flat" cmpd="sng" algn="ctr">
+          <a:solidFill>
+            <a:schemeClr val="phClr"/>
+          </a:solidFill>
+          <a:prstDash val="solid"/>
+        </a:ln>
+      </a:lnStyleLst>
+      <a:effectStyleLst>
+        <a:effectStyle>
+          <a:effectLst>
+            <a:outerShdw blurRad="40000" dist="20000" dir="5400000" rotWithShape="0">
+              <a:srgbClr val="000000">
+                <a:alpha val="38000"/>
+              </a:srgbClr>
+            </a:outerShdw>
+          </a:effectLst>
+        </a:effectStyle>
+        <a:effectStyle>
+          <a:effectLst>
+            <a:outerShdw blurRad="40000" dist="23000" dir="5400000" rotWithShape="0">
+              <a:srgbClr val="000000">
+                <a:alpha val="35000"/>
+              </a:srgbClr>
+            </a:outerShdw>
+          </a:effectLst>
+        </a:effectStyle>
+        <a:effectStyle>
+          <a:effectLst>
+            <a:outerShdw blurRad="40000" dist="23000" dir="5400000" rotWithShape="0">
+              <a:srgbClr val="000000">
+                <a:alpha val="35000"/>
+              </a:srgbClr>
+            </a:outerShdw>
+          </a:effectLst>
+          <a:scene3d>
+            <a:camera prst="orthographicFront">
+              <a:rot lat="0" lon="0" rev="0"/>
+            </a:camera>
+            <a:lightRig rig="threePt" dir="t">
+              <a:rot lat="0" lon="0" rev="1200000"/>
+            </a:lightRig>
+          </a:scene3d>
+          <a:sp3d>
+            <a:bevelT w="63500" h="25400"/>
+          </a:sp3d>
+        </a:effectStyle>
+      </a:effectStyleLst>
+      <a:bgFillStyleLst>
+        <a:solidFill>
+          <a:schemeClr val="phClr"/>
+        </a:solidFill>
+        <a:gradFill rotWithShape="1">
+          <a:gsLst>
+            <a:gs pos="0">
+              <a:schemeClr val="phClr">
+                <a:tint val="40000"/>
+                <a:satMod val="350000"/>
+              </a:schemeClr>
+            </a:gs>
+            <a:gs pos="40000">
+              <a:schemeClr val="phClr">
+                <a:tint val="45000"/>
+                <a:shade val="99000"/>
+                <a:satMod val="350000"/>
+              </a:schemeClr>
+            </a:gs>
+            <a:gs pos="100000">
+              <a:schemeClr val="phClr">
+                <a:shade val="20000"/>
+                <a:satMod val="255000"/>
+              </a:schemeClr>
+            </a:gs>
+          </a:gsLst>
+          <a:path path="circle">
+            <a:fillToRect l="50000" t="-80000" r="50000" b="180000"/>
+          </a:path>
+        </a:gradFill>
+        <a:gradFill rotWithShape="1">
+          <a:gsLst>
+            <a:gs pos="0">
+              <a:schemeClr val="phClr">
+                <a:tint val="80000"/>
+                <a:satMod val="300000"/>
+              </a:schemeClr>
+            </a:gs>
+            <a:gs pos="100000">
+              <a:schemeClr val="phClr">
+                <a:shade val="30000"/>
+                <a:satMod val="200000"/>
+              </a:schemeClr>
+            </a:gs>
+          </a:gsLst>
+          <a:path path="circle">
+            <a:fillToRect l="50000" t="50000" r="50000" b="50000"/>
+          </a:path>
+        </a:gradFill>
+      </a:bgFillStyleLst>
+    </a:fmtScheme>
+  </a:themeElements>
+  <a:objectDefaults>
+    <a:spDef>
+      <a:spPr/>
+      <a:bodyPr/>
+      <a:lstStyle/>
+      <a:style>
+        <a:lnRef idx="1">
+          <a:schemeClr val="accent1"/>
+        </a:lnRef>
+        <a:fillRef idx="3">
+          <a:schemeClr val="accent1"/>
+        </a:fillRef>
+        <a:effectRef idx="2">
+          <a:schemeClr val="accent1"/>
+        </a:effectRef>
+        <a:fontRef idx="minor">
+          <a:schemeClr val="lt1"/>
+        </a:fontRef>
+      </a:style>
+    </a:spDef>
+    <a:lnDef>
+      <a:spPr/>
+      <a:bodyPr/>
+      <a:lstStyle/>
+      <a:style>
+        <a:lnRef idx="2">
+          <a:schemeClr val="accent1"/>
+        </a:lnRef>
+        <a:fillRef idx="0">
+          <a:schemeClr val="accent1"/>
+        </a:fillRef>
+        <a:effectRef idx="1">
+          <a:schemeClr val="accent1"/>
+        </a:effectRef>
+        <a:fontRef idx="minor">
+          <a:schemeClr val="tx1"/>
+        </a:fontRef>
+      </a:style>
+    </a:lnDef>
+  </a:objectDefaults>
+  <a:extraClrSchemeLst/>
+</a:theme>
 </file>
</xml_diff>